<commit_message>
feat(project-07): finalize 100% complete implementation, models, tests, docs, PPT, and video demonstration for PROJECT-007
</commit_message>
<xml_diff>
--- a/project_07_crop_yield_prediction/presentations/project_presentation.pptx
+++ b/project_07_crop_yield_prediction/presentations/project_presentation.pptx
@@ -13,6 +13,13 @@
     <p:sldId id="261" r:id="rId12"/>
     <p:sldId id="262" r:id="rId13"/>
     <p:sldId id="263" r:id="rId14"/>
+    <p:sldId id="264" r:id="rId15"/>
+    <p:sldId id="265" r:id="rId16"/>
+    <p:sldId id="266" r:id="rId17"/>
+    <p:sldId id="267" r:id="rId18"/>
+    <p:sldId id="268" r:id="rId19"/>
+    <p:sldId id="269" r:id="rId20"/>
+    <p:sldId id="270" r:id="rId21"/>
   </p:sldIdLst>
   <p:sldSz cx="12191695" cy="6858000" type="screen4x3"/>
   <p:notesSz cx="6858000" cy="9144000"/>
@@ -3146,8 +3153,8 @@
         </p:nvSpPr>
         <p:spPr>
           <a:xfrm>
-            <a:off x="1097280" y="1645920"/>
-            <a:ext cx="10058400" cy="3474720"/>
+            <a:off x="914400" y="1828800"/>
+            <a:ext cx="10362895" cy="3200400"/>
           </a:xfrm>
           <a:prstGeom prst="rect">
             <a:avLst/>
@@ -3161,44 +3168,1189 @@
           <a:lstStyle/>
           <a:p>
             <a:pPr>
-              <a:defRPr sz="1400" b="1">
+              <a:defRPr sz="1300" b="1">
+                <a:solidFill>
+                  <a:srgbClr val="22C55E"/>
+                </a:solidFill>
+              </a:defRPr>
+            </a:pPr>
+            <a:r>
+              <a:t>PROJECT 07 OF 55 • PRECISION AGRICULTURE &amp; DATA SCIENCE</a:t>
+            </a:r>
+          </a:p>
+          <a:p>
+            <a:pPr>
+              <a:defRPr sz="3600" b="1">
+                <a:solidFill>
+                  <a:srgbClr val="F8FAFC"/>
+                </a:solidFill>
+              </a:defRPr>
+            </a:pPr>
+            <a:r>
+              <a:t>Crop Yield Prediction Using Machine Learning</a:t>
+            </a:r>
+            <a:br/>
+            <a:r>
+              <a:t>&amp; Agronomic Climate Adaptation Algorithms</a:t>
+            </a:r>
+          </a:p>
+          <a:p>
+            <a:pPr>
+              <a:defRPr sz="1500">
+                <a:solidFill>
+                  <a:srgbClr val="94A3B8"/>
+                </a:solidFill>
+              </a:defRPr>
+            </a:pPr>
+            <a:r>
+              <a:t>Global FAO Multilateral Dataset • 28,242 Records • 115 Encoded Features • Random Forest 98.5% R² • Port 5007</a:t>
+            </a:r>
+          </a:p>
+        </p:txBody>
+      </p:sp>
+    </p:spTree>
+  </p:cSld>
+  <p:clrMapOvr>
+    <a:masterClrMapping/>
+  </p:clrMapOvr>
+</p:sld>
+</file>
+
+<file path=ppt/slides/slide10.xml><?xml version="1.0" encoding="utf-8"?>
+<p:sld xmlns:a="http://schemas.openxmlformats.org/drawingml/2006/main" xmlns:p="http://schemas.openxmlformats.org/presentationml/2006/main" xmlns:r="http://schemas.openxmlformats.org/officeDocument/2006/relationships">
+  <p:cSld>
+    <p:spTree>
+      <p:nvGrpSpPr>
+        <p:cNvPr id="1" name=""/>
+        <p:cNvGrpSpPr/>
+        <p:nvPr/>
+      </p:nvGrpSpPr>
+      <p:grpSpPr/>
+      <p:sp>
+        <p:nvSpPr>
+          <p:cNvPr id="2" name="Rectangle 1"/>
+          <p:cNvSpPr/>
+          <p:nvPr/>
+        </p:nvSpPr>
+        <p:spPr>
+          <a:xfrm>
+            <a:off x="0" y="0"/>
+            <a:ext cx="12191695" cy="6858000"/>
+          </a:xfrm>
+          <a:prstGeom prst="rect">
+            <a:avLst/>
+          </a:prstGeom>
+          <a:solidFill>
+            <a:srgbClr val="0F172A"/>
+          </a:solidFill>
+          <a:ln>
+            <a:noFill/>
+          </a:ln>
+        </p:spPr>
+        <p:style>
+          <a:lnRef idx="1">
+            <a:schemeClr val="accent1"/>
+          </a:lnRef>
+          <a:fillRef idx="3">
+            <a:schemeClr val="accent1"/>
+          </a:fillRef>
+          <a:effectRef idx="2">
+            <a:schemeClr val="accent1"/>
+          </a:effectRef>
+          <a:fontRef idx="minor">
+            <a:schemeClr val="lt1"/>
+          </a:fontRef>
+        </p:style>
+        <p:txBody>
+          <a:bodyPr rtlCol="0" anchor="ctr"/>
+          <a:lstStyle/>
+          <a:p>
+            <a:pPr algn="ctr"/>
+          </a:p>
+        </p:txBody>
+      </p:sp>
+      <p:sp>
+        <p:nvSpPr>
+          <p:cNvPr id="3" name="TextBox 2"/>
+          <p:cNvSpPr txBox="1"/>
+          <p:nvPr/>
+        </p:nvSpPr>
+        <p:spPr>
+          <a:xfrm>
+            <a:off x="731520" y="457200"/>
+            <a:ext cx="10728655" cy="1005840"/>
+          </a:xfrm>
+          <a:prstGeom prst="rect">
+            <a:avLst/>
+          </a:prstGeom>
+          <a:noFill/>
+        </p:spPr>
+        <p:txBody>
+          <a:bodyPr wrap="square">
+            <a:spAutoFit/>
+          </a:bodyPr>
+          <a:lstStyle/>
+          <a:p>
+            <a:pPr>
+              <a:defRPr sz="1100" b="1">
+                <a:solidFill>
+                  <a:srgbClr val="22C55E"/>
+                </a:solidFill>
+              </a:defRPr>
+            </a:pPr>
+            <a:r>
+              <a:t>AGRONOMIC INFORMATICS &amp; CLIMATE-SMART AGRICULTURE</a:t>
+            </a:r>
+          </a:p>
+          <a:p>
+            <a:pPr>
+              <a:defRPr sz="2200" b="1">
+                <a:solidFill>
+                  <a:srgbClr val="F8FAFC"/>
+                </a:solidFill>
+              </a:defRPr>
+            </a:pPr>
+            <a:r>
+              <a:t>Yield Density &amp; Harvest Tonnage Computation</a:t>
+            </a:r>
+          </a:p>
+        </p:txBody>
+      </p:sp>
+      <p:pic>
+        <p:nvPicPr>
+          <p:cNvPr id="4" name="Picture 3" descr="03_yield_prediction_result.png"/>
+          <p:cNvPicPr>
+            <a:picLocks noChangeAspect="1"/>
+          </p:cNvPicPr>
+          <p:nvPr/>
+        </p:nvPicPr>
+        <p:blipFill>
+          <a:blip r:embed="rId2"/>
+          <a:stretch>
+            <a:fillRect/>
+          </a:stretch>
+        </p:blipFill>
+        <p:spPr>
+          <a:xfrm>
+            <a:off x="731520" y="1645920"/>
+            <a:ext cx="6583680" cy="4114800"/>
+          </a:xfrm>
+          <a:prstGeom prst="rect">
+            <a:avLst/>
+          </a:prstGeom>
+        </p:spPr>
+      </p:pic>
+      <p:sp>
+        <p:nvSpPr>
+          <p:cNvPr id="5" name="TextBox 4"/>
+          <p:cNvSpPr txBox="1"/>
+          <p:nvPr/>
+        </p:nvSpPr>
+        <p:spPr>
+          <a:xfrm>
+            <a:off x="7589520" y="1645920"/>
+            <a:ext cx="3840480" cy="4572000"/>
+          </a:xfrm>
+          <a:prstGeom prst="rect">
+            <a:avLst/>
+          </a:prstGeom>
+          <a:noFill/>
+        </p:spPr>
+        <p:txBody>
+          <a:bodyPr wrap="square">
+            <a:spAutoFit/>
+          </a:bodyPr>
+          <a:lstStyle/>
+          <a:p>
+            <a:pPr>
+              <a:defRPr b="1" sz="1300">
+                <a:solidFill>
+                  <a:srgbClr val="10B981"/>
+                </a:solidFill>
+              </a:defRPr>
+            </a:pPr>
+            <a:r>
+              <a:t>YIELD INFERENCE RESULTS</a:t>
+            </a:r>
+          </a:p>
+          <a:p>
+            <a:pPr>
+              <a:defRPr sz="1200">
+                <a:solidFill>
+                  <a:srgbClr val="F8FAFC"/>
+                </a:solidFill>
+              </a:defRPr>
+            </a:pPr>
+            <a:r>
+              <a:t>• Computes expected yield density in hg/ha (e.g. 52,480 hg/ha for Albania Maize).</a:t>
+            </a:r>
+            <a:br/>
+            <a:r>
+              <a:t>• Converts yield into total expected farm harvest in Metric Tonnes and Kilograms.</a:t>
+            </a:r>
+            <a:br/>
+            <a:r>
+              <a:t>• Displays 95% confidence intervals and historical peer averages.</a:t>
+            </a:r>
+          </a:p>
+        </p:txBody>
+      </p:sp>
+    </p:spTree>
+  </p:cSld>
+  <p:clrMapOvr>
+    <a:masterClrMapping/>
+  </p:clrMapOvr>
+</p:sld>
+</file>
+
+<file path=ppt/slides/slide11.xml><?xml version="1.0" encoding="utf-8"?>
+<p:sld xmlns:a="http://schemas.openxmlformats.org/drawingml/2006/main" xmlns:p="http://schemas.openxmlformats.org/presentationml/2006/main" xmlns:r="http://schemas.openxmlformats.org/officeDocument/2006/relationships">
+  <p:cSld>
+    <p:spTree>
+      <p:nvGrpSpPr>
+        <p:cNvPr id="1" name=""/>
+        <p:cNvGrpSpPr/>
+        <p:nvPr/>
+      </p:nvGrpSpPr>
+      <p:grpSpPr/>
+      <p:sp>
+        <p:nvSpPr>
+          <p:cNvPr id="2" name="Rectangle 1"/>
+          <p:cNvSpPr/>
+          <p:nvPr/>
+        </p:nvSpPr>
+        <p:spPr>
+          <a:xfrm>
+            <a:off x="0" y="0"/>
+            <a:ext cx="12191695" cy="6858000"/>
+          </a:xfrm>
+          <a:prstGeom prst="rect">
+            <a:avLst/>
+          </a:prstGeom>
+          <a:solidFill>
+            <a:srgbClr val="0F172A"/>
+          </a:solidFill>
+          <a:ln>
+            <a:noFill/>
+          </a:ln>
+        </p:spPr>
+        <p:style>
+          <a:lnRef idx="1">
+            <a:schemeClr val="accent1"/>
+          </a:lnRef>
+          <a:fillRef idx="3">
+            <a:schemeClr val="accent1"/>
+          </a:fillRef>
+          <a:effectRef idx="2">
+            <a:schemeClr val="accent1"/>
+          </a:effectRef>
+          <a:fontRef idx="minor">
+            <a:schemeClr val="lt1"/>
+          </a:fontRef>
+        </p:style>
+        <p:txBody>
+          <a:bodyPr rtlCol="0" anchor="ctr"/>
+          <a:lstStyle/>
+          <a:p>
+            <a:pPr algn="ctr"/>
+          </a:p>
+        </p:txBody>
+      </p:sp>
+      <p:sp>
+        <p:nvSpPr>
+          <p:cNvPr id="3" name="TextBox 2"/>
+          <p:cNvSpPr txBox="1"/>
+          <p:nvPr/>
+        </p:nvSpPr>
+        <p:spPr>
+          <a:xfrm>
+            <a:off x="731520" y="457200"/>
+            <a:ext cx="10728655" cy="1005840"/>
+          </a:xfrm>
+          <a:prstGeom prst="rect">
+            <a:avLst/>
+          </a:prstGeom>
+          <a:noFill/>
+        </p:spPr>
+        <p:txBody>
+          <a:bodyPr wrap="square">
+            <a:spAutoFit/>
+          </a:bodyPr>
+          <a:lstStyle/>
+          <a:p>
+            <a:pPr>
+              <a:defRPr sz="1100" b="1">
+                <a:solidFill>
+                  <a:srgbClr val="22C55E"/>
+                </a:solidFill>
+              </a:defRPr>
+            </a:pPr>
+            <a:r>
+              <a:t>AGRONOMIC INFORMATICS &amp; CLIMATE-SMART AGRICULTURE</a:t>
+            </a:r>
+          </a:p>
+          <a:p>
+            <a:pPr>
+              <a:defRPr sz="2200" b="1">
+                <a:solidFill>
+                  <a:srgbClr val="F8FAFC"/>
+                </a:solidFill>
+              </a:defRPr>
+            </a:pPr>
+            <a:r>
+              <a:t>Climate-Smart Crop Recommendation Engine</a:t>
+            </a:r>
+          </a:p>
+        </p:txBody>
+      </p:sp>
+      <p:pic>
+        <p:nvPicPr>
+          <p:cNvPr id="4" name="Picture 3" descr="04_crop_recommendations.png"/>
+          <p:cNvPicPr>
+            <a:picLocks noChangeAspect="1"/>
+          </p:cNvPicPr>
+          <p:nvPr/>
+        </p:nvPicPr>
+        <p:blipFill>
+          <a:blip r:embed="rId2"/>
+          <a:stretch>
+            <a:fillRect/>
+          </a:stretch>
+        </p:blipFill>
+        <p:spPr>
+          <a:xfrm>
+            <a:off x="731520" y="1645920"/>
+            <a:ext cx="6583680" cy="4114800"/>
+          </a:xfrm>
+          <a:prstGeom prst="rect">
+            <a:avLst/>
+          </a:prstGeom>
+        </p:spPr>
+      </p:pic>
+      <p:sp>
+        <p:nvSpPr>
+          <p:cNvPr id="5" name="TextBox 4"/>
+          <p:cNvSpPr txBox="1"/>
+          <p:nvPr/>
+        </p:nvSpPr>
+        <p:spPr>
+          <a:xfrm>
+            <a:off x="7589520" y="1645920"/>
+            <a:ext cx="3840480" cy="4572000"/>
+          </a:xfrm>
+          <a:prstGeom prst="rect">
+            <a:avLst/>
+          </a:prstGeom>
+          <a:noFill/>
+        </p:spPr>
+        <p:txBody>
+          <a:bodyPr wrap="square">
+            <a:spAutoFit/>
+          </a:bodyPr>
+          <a:lstStyle/>
+          <a:p>
+            <a:pPr>
+              <a:defRPr b="1" sz="1300">
+                <a:solidFill>
+                  <a:srgbClr val="F59E0B"/>
+                </a:solidFill>
+              </a:defRPr>
+            </a:pPr>
+            <a:r>
+              <a:t>RECOMMENDATION MATRIX</a:t>
+            </a:r>
+          </a:p>
+          <a:p>
+            <a:pPr>
+              <a:defRPr sz="1200">
+                <a:solidFill>
+                  <a:srgbClr val="F8FAFC"/>
+                </a:solidFill>
+              </a:defRPr>
+            </a:pPr>
+            <a:r>
+              <a:t>• Simultaneously evaluates all 10 candidate crops under given climate inputs.</a:t>
+            </a:r>
+            <a:br/>
+            <a:r>
+              <a:t>• Highlights Top-3 recommended crops with highest predicted yield density.</a:t>
+            </a:r>
+            <a:br/>
+            <a:r>
+              <a:t>• Enables agricultural advisors to recommend resilient, high-yield substitutes.</a:t>
+            </a:r>
+          </a:p>
+        </p:txBody>
+      </p:sp>
+    </p:spTree>
+  </p:cSld>
+  <p:clrMapOvr>
+    <a:masterClrMapping/>
+  </p:clrMapOvr>
+</p:sld>
+</file>
+
+<file path=ppt/slides/slide12.xml><?xml version="1.0" encoding="utf-8"?>
+<p:sld xmlns:a="http://schemas.openxmlformats.org/drawingml/2006/main" xmlns:p="http://schemas.openxmlformats.org/presentationml/2006/main" xmlns:r="http://schemas.openxmlformats.org/officeDocument/2006/relationships">
+  <p:cSld>
+    <p:spTree>
+      <p:nvGrpSpPr>
+        <p:cNvPr id="1" name=""/>
+        <p:cNvGrpSpPr/>
+        <p:nvPr/>
+      </p:nvGrpSpPr>
+      <p:grpSpPr/>
+      <p:sp>
+        <p:nvSpPr>
+          <p:cNvPr id="2" name="Rectangle 1"/>
+          <p:cNvSpPr/>
+          <p:nvPr/>
+        </p:nvSpPr>
+        <p:spPr>
+          <a:xfrm>
+            <a:off x="0" y="0"/>
+            <a:ext cx="12191695" cy="6858000"/>
+          </a:xfrm>
+          <a:prstGeom prst="rect">
+            <a:avLst/>
+          </a:prstGeom>
+          <a:solidFill>
+            <a:srgbClr val="0F172A"/>
+          </a:solidFill>
+          <a:ln>
+            <a:noFill/>
+          </a:ln>
+        </p:spPr>
+        <p:style>
+          <a:lnRef idx="1">
+            <a:schemeClr val="accent1"/>
+          </a:lnRef>
+          <a:fillRef idx="3">
+            <a:schemeClr val="accent1"/>
+          </a:fillRef>
+          <a:effectRef idx="2">
+            <a:schemeClr val="accent1"/>
+          </a:effectRef>
+          <a:fontRef idx="minor">
+            <a:schemeClr val="lt1"/>
+          </a:fontRef>
+        </p:style>
+        <p:txBody>
+          <a:bodyPr rtlCol="0" anchor="ctr"/>
+          <a:lstStyle/>
+          <a:p>
+            <a:pPr algn="ctr"/>
+          </a:p>
+        </p:txBody>
+      </p:sp>
+      <p:sp>
+        <p:nvSpPr>
+          <p:cNvPr id="3" name="TextBox 2"/>
+          <p:cNvSpPr txBox="1"/>
+          <p:nvPr/>
+        </p:nvSpPr>
+        <p:spPr>
+          <a:xfrm>
+            <a:off x="731520" y="457200"/>
+            <a:ext cx="10728655" cy="1005840"/>
+          </a:xfrm>
+          <a:prstGeom prst="rect">
+            <a:avLst/>
+          </a:prstGeom>
+          <a:noFill/>
+        </p:spPr>
+        <p:txBody>
+          <a:bodyPr wrap="square">
+            <a:spAutoFit/>
+          </a:bodyPr>
+          <a:lstStyle/>
+          <a:p>
+            <a:pPr>
+              <a:defRPr sz="1100" b="1">
+                <a:solidFill>
+                  <a:srgbClr val="22C55E"/>
+                </a:solidFill>
+              </a:defRPr>
+            </a:pPr>
+            <a:r>
+              <a:t>AGRONOMIC INFORMATICS &amp; CLIMATE-SMART AGRICULTURE</a:t>
+            </a:r>
+          </a:p>
+          <a:p>
+            <a:pPr>
+              <a:defRPr sz="2200" b="1">
+                <a:solidFill>
+                  <a:srgbClr val="F8FAFC"/>
+                </a:solidFill>
+              </a:defRPr>
+            </a:pPr>
+            <a:r>
+              <a:t>Model Comparison &amp; Benchmarking Table</a:t>
+            </a:r>
+          </a:p>
+        </p:txBody>
+      </p:sp>
+      <p:pic>
+        <p:nvPicPr>
+          <p:cNvPr id="4" name="Picture 3" descr="05_model_benchmarks_regression.png"/>
+          <p:cNvPicPr>
+            <a:picLocks noChangeAspect="1"/>
+          </p:cNvPicPr>
+          <p:nvPr/>
+        </p:nvPicPr>
+        <p:blipFill>
+          <a:blip r:embed="rId2"/>
+          <a:stretch>
+            <a:fillRect/>
+          </a:stretch>
+        </p:blipFill>
+        <p:spPr>
+          <a:xfrm>
+            <a:off x="731520" y="1645920"/>
+            <a:ext cx="6583680" cy="4114800"/>
+          </a:xfrm>
+          <a:prstGeom prst="rect">
+            <a:avLst/>
+          </a:prstGeom>
+        </p:spPr>
+      </p:pic>
+      <p:sp>
+        <p:nvSpPr>
+          <p:cNvPr id="5" name="TextBox 4"/>
+          <p:cNvSpPr txBox="1"/>
+          <p:nvPr/>
+        </p:nvSpPr>
+        <p:spPr>
+          <a:xfrm>
+            <a:off x="7589520" y="1645920"/>
+            <a:ext cx="3840480" cy="4572000"/>
+          </a:xfrm>
+          <a:prstGeom prst="rect">
+            <a:avLst/>
+          </a:prstGeom>
+          <a:noFill/>
+        </p:spPr>
+        <p:txBody>
+          <a:bodyPr wrap="square">
+            <a:spAutoFit/>
+          </a:bodyPr>
+          <a:lstStyle/>
+          <a:p>
+            <a:pPr>
+              <a:defRPr b="1" sz="1300">
                 <a:solidFill>
                   <a:srgbClr val="38BDF8"/>
                 </a:solidFill>
               </a:defRPr>
             </a:pPr>
             <a:r>
-              <a:t>PROJECT 07 OF 55  •  RESEARCH &amp; IMPLEMENTATION DECK</a:t>
-            </a:r>
-          </a:p>
-          <a:p>
-            <a:pPr>
-              <a:spcBef>
-                <a:spcPts val="1400"/>
-              </a:spcBef>
-              <a:defRPr sz="3200" b="1">
-                <a:solidFill>
-                  <a:srgbClr val="FFFFFF"/>
-                </a:solidFill>
-              </a:defRPr>
-            </a:pPr>
-            <a:r>
-              <a:t>Crop Yield Prediction using Machine Learning Algorithms</a:t>
-            </a:r>
-          </a:p>
-          <a:p>
-            <a:pPr>
-              <a:spcBef>
-                <a:spcPts val="1200"/>
-              </a:spcBef>
-              <a:defRPr sz="1600">
-                <a:solidFill>
-                  <a:srgbClr val="CBD5E1"/>
-                </a:solidFill>
-              </a:defRPr>
-            </a:pPr>
-            <a:r>
-              <a:t>Enterprise-Grade AI Architecture, Machine Learning Pipeline &amp; Deployment Framework</a:t>
+              <a:t>BENCHMARK METRICS</a:t>
+            </a:r>
+          </a:p>
+          <a:p>
+            <a:pPr>
+              <a:defRPr sz="1200">
+                <a:solidFill>
+                  <a:srgbClr val="F8FAFC"/>
+                </a:solidFill>
+              </a:defRPr>
+            </a:pPr>
+            <a:r>
+              <a:t>• Comparative evaluation across 5 regression models.</a:t>
+            </a:r>
+            <a:br/>
+            <a:r>
+              <a:t>• Tracks R², RMSE, MAE, and inference latency.</a:t>
+            </a:r>
+            <a:br/>
+            <a:r>
+              <a:t>• Demonstrates Random Forest's empirical superiority (98.5% variance explained).</a:t>
+            </a:r>
+          </a:p>
+        </p:txBody>
+      </p:sp>
+    </p:spTree>
+  </p:cSld>
+  <p:clrMapOvr>
+    <a:masterClrMapping/>
+  </p:clrMapOvr>
+</p:sld>
+</file>
+
+<file path=ppt/slides/slide13.xml><?xml version="1.0" encoding="utf-8"?>
+<p:sld xmlns:a="http://schemas.openxmlformats.org/drawingml/2006/main" xmlns:p="http://schemas.openxmlformats.org/presentationml/2006/main" xmlns:r="http://schemas.openxmlformats.org/officeDocument/2006/relationships">
+  <p:cSld>
+    <p:spTree>
+      <p:nvGrpSpPr>
+        <p:cNvPr id="1" name=""/>
+        <p:cNvGrpSpPr/>
+        <p:nvPr/>
+      </p:nvGrpSpPr>
+      <p:grpSpPr/>
+      <p:sp>
+        <p:nvSpPr>
+          <p:cNvPr id="2" name="Rectangle 1"/>
+          <p:cNvSpPr/>
+          <p:nvPr/>
+        </p:nvSpPr>
+        <p:spPr>
+          <a:xfrm>
+            <a:off x="0" y="0"/>
+            <a:ext cx="12191695" cy="6858000"/>
+          </a:xfrm>
+          <a:prstGeom prst="rect">
+            <a:avLst/>
+          </a:prstGeom>
+          <a:solidFill>
+            <a:srgbClr val="0F172A"/>
+          </a:solidFill>
+          <a:ln>
+            <a:noFill/>
+          </a:ln>
+        </p:spPr>
+        <p:style>
+          <a:lnRef idx="1">
+            <a:schemeClr val="accent1"/>
+          </a:lnRef>
+          <a:fillRef idx="3">
+            <a:schemeClr val="accent1"/>
+          </a:fillRef>
+          <a:effectRef idx="2">
+            <a:schemeClr val="accent1"/>
+          </a:effectRef>
+          <a:fontRef idx="minor">
+            <a:schemeClr val="lt1"/>
+          </a:fontRef>
+        </p:style>
+        <p:txBody>
+          <a:bodyPr rtlCol="0" anchor="ctr"/>
+          <a:lstStyle/>
+          <a:p>
+            <a:pPr algn="ctr"/>
+          </a:p>
+        </p:txBody>
+      </p:sp>
+      <p:sp>
+        <p:nvSpPr>
+          <p:cNvPr id="3" name="TextBox 2"/>
+          <p:cNvSpPr txBox="1"/>
+          <p:nvPr/>
+        </p:nvSpPr>
+        <p:spPr>
+          <a:xfrm>
+            <a:off x="731520" y="457200"/>
+            <a:ext cx="10728655" cy="1005840"/>
+          </a:xfrm>
+          <a:prstGeom prst="rect">
+            <a:avLst/>
+          </a:prstGeom>
+          <a:noFill/>
+        </p:spPr>
+        <p:txBody>
+          <a:bodyPr wrap="square">
+            <a:spAutoFit/>
+          </a:bodyPr>
+          <a:lstStyle/>
+          <a:p>
+            <a:pPr>
+              <a:defRPr sz="1100" b="1">
+                <a:solidFill>
+                  <a:srgbClr val="22C55E"/>
+                </a:solidFill>
+              </a:defRPr>
+            </a:pPr>
+            <a:r>
+              <a:t>AGRONOMIC INFORMATICS &amp; CLIMATE-SMART AGRICULTURE</a:t>
+            </a:r>
+          </a:p>
+          <a:p>
+            <a:pPr>
+              <a:defRPr sz="2200" b="1">
+                <a:solidFill>
+                  <a:srgbClr val="F8FAFC"/>
+                </a:solidFill>
+              </a:defRPr>
+            </a:pPr>
+            <a:r>
+              <a:t>Exploratory Agronomic Data Analysis &amp; Correlations</a:t>
+            </a:r>
+          </a:p>
+        </p:txBody>
+      </p:sp>
+      <p:pic>
+        <p:nvPicPr>
+          <p:cNvPr id="4" name="Picture 3" descr="06_data_exploration_analytics.png"/>
+          <p:cNvPicPr>
+            <a:picLocks noChangeAspect="1"/>
+          </p:cNvPicPr>
+          <p:nvPr/>
+        </p:nvPicPr>
+        <p:blipFill>
+          <a:blip r:embed="rId2"/>
+          <a:stretch>
+            <a:fillRect/>
+          </a:stretch>
+        </p:blipFill>
+        <p:spPr>
+          <a:xfrm>
+            <a:off x="731520" y="1645920"/>
+            <a:ext cx="6583680" cy="4114800"/>
+          </a:xfrm>
+          <a:prstGeom prst="rect">
+            <a:avLst/>
+          </a:prstGeom>
+        </p:spPr>
+      </p:pic>
+      <p:sp>
+        <p:nvSpPr>
+          <p:cNvPr id="5" name="TextBox 4"/>
+          <p:cNvSpPr txBox="1"/>
+          <p:nvPr/>
+        </p:nvSpPr>
+        <p:spPr>
+          <a:xfrm>
+            <a:off x="7589520" y="1645920"/>
+            <a:ext cx="3840480" cy="4572000"/>
+          </a:xfrm>
+          <a:prstGeom prst="rect">
+            <a:avLst/>
+          </a:prstGeom>
+          <a:noFill/>
+        </p:spPr>
+        <p:txBody>
+          <a:bodyPr wrap="square">
+            <a:spAutoFit/>
+          </a:bodyPr>
+          <a:lstStyle/>
+          <a:p>
+            <a:pPr>
+              <a:defRPr b="1" sz="1300">
+                <a:solidFill>
+                  <a:srgbClr val="22C55E"/>
+                </a:solidFill>
+              </a:defRPr>
+            </a:pPr>
+            <a:r>
+              <a:t>DATA EXPLORATION</a:t>
+            </a:r>
+          </a:p>
+          <a:p>
+            <a:pPr>
+              <a:defRPr sz="1200">
+                <a:solidFill>
+                  <a:srgbClr val="F8FAFC"/>
+                </a:solidFill>
+              </a:defRPr>
+            </a:pPr>
+            <a:r>
+              <a:t>• Visualizes multi-decadal yield trends across nations.</a:t>
+            </a:r>
+            <a:br/>
+            <a:r>
+              <a:t>• Correlation matrices between rainfall, temperature, and pesticide efficiency.</a:t>
+            </a:r>
+            <a:br/>
+            <a:r>
+              <a:t>• Outlier detection identifying exceptionally high-performing agricultural regions.</a:t>
+            </a:r>
+          </a:p>
+        </p:txBody>
+      </p:sp>
+    </p:spTree>
+  </p:cSld>
+  <p:clrMapOvr>
+    <a:masterClrMapping/>
+  </p:clrMapOvr>
+</p:sld>
+</file>
+
+<file path=ppt/slides/slide14.xml><?xml version="1.0" encoding="utf-8"?>
+<p:sld xmlns:a="http://schemas.openxmlformats.org/drawingml/2006/main" xmlns:p="http://schemas.openxmlformats.org/presentationml/2006/main" xmlns:r="http://schemas.openxmlformats.org/officeDocument/2006/relationships">
+  <p:cSld>
+    <p:spTree>
+      <p:nvGrpSpPr>
+        <p:cNvPr id="1" name=""/>
+        <p:cNvGrpSpPr/>
+        <p:nvPr/>
+      </p:nvGrpSpPr>
+      <p:grpSpPr/>
+      <p:sp>
+        <p:nvSpPr>
+          <p:cNvPr id="2" name="Rectangle 1"/>
+          <p:cNvSpPr/>
+          <p:nvPr/>
+        </p:nvSpPr>
+        <p:spPr>
+          <a:xfrm>
+            <a:off x="0" y="0"/>
+            <a:ext cx="12191695" cy="6858000"/>
+          </a:xfrm>
+          <a:prstGeom prst="rect">
+            <a:avLst/>
+          </a:prstGeom>
+          <a:solidFill>
+            <a:srgbClr val="0F172A"/>
+          </a:solidFill>
+          <a:ln>
+            <a:noFill/>
+          </a:ln>
+        </p:spPr>
+        <p:style>
+          <a:lnRef idx="1">
+            <a:schemeClr val="accent1"/>
+          </a:lnRef>
+          <a:fillRef idx="3">
+            <a:schemeClr val="accent1"/>
+          </a:fillRef>
+          <a:effectRef idx="2">
+            <a:schemeClr val="accent1"/>
+          </a:effectRef>
+          <a:fontRef idx="minor">
+            <a:schemeClr val="lt1"/>
+          </a:fontRef>
+        </p:style>
+        <p:txBody>
+          <a:bodyPr rtlCol="0" anchor="ctr"/>
+          <a:lstStyle/>
+          <a:p>
+            <a:pPr algn="ctr"/>
+          </a:p>
+        </p:txBody>
+      </p:sp>
+      <p:sp>
+        <p:nvSpPr>
+          <p:cNvPr id="3" name="TextBox 2"/>
+          <p:cNvSpPr txBox="1"/>
+          <p:nvPr/>
+        </p:nvSpPr>
+        <p:spPr>
+          <a:xfrm>
+            <a:off x="731520" y="457200"/>
+            <a:ext cx="10728655" cy="1005840"/>
+          </a:xfrm>
+          <a:prstGeom prst="rect">
+            <a:avLst/>
+          </a:prstGeom>
+          <a:noFill/>
+        </p:spPr>
+        <p:txBody>
+          <a:bodyPr wrap="square">
+            <a:spAutoFit/>
+          </a:bodyPr>
+          <a:lstStyle/>
+          <a:p>
+            <a:pPr>
+              <a:defRPr sz="1100" b="1">
+                <a:solidFill>
+                  <a:srgbClr val="22C55E"/>
+                </a:solidFill>
+              </a:defRPr>
+            </a:pPr>
+            <a:r>
+              <a:t>AGRONOMIC INFORMATICS &amp; CLIMATE-SMART AGRICULTURE</a:t>
+            </a:r>
+          </a:p>
+          <a:p>
+            <a:pPr>
+              <a:defRPr sz="2200" b="1">
+                <a:solidFill>
+                  <a:srgbClr val="F8FAFC"/>
+                </a:solidFill>
+              </a:defRPr>
+            </a:pPr>
+            <a:r>
+              <a:t>Feature Importance Hierarchy &amp; Environmental Drivers</a:t>
+            </a:r>
+          </a:p>
+        </p:txBody>
+      </p:sp>
+      <p:pic>
+        <p:nvPicPr>
+          <p:cNvPr id="4" name="Picture 3" descr="07_feature_importance_visuals.png"/>
+          <p:cNvPicPr>
+            <a:picLocks noChangeAspect="1"/>
+          </p:cNvPicPr>
+          <p:nvPr/>
+        </p:nvPicPr>
+        <p:blipFill>
+          <a:blip r:embed="rId2"/>
+          <a:stretch>
+            <a:fillRect/>
+          </a:stretch>
+        </p:blipFill>
+        <p:spPr>
+          <a:xfrm>
+            <a:off x="731520" y="1645920"/>
+            <a:ext cx="6583680" cy="4114800"/>
+          </a:xfrm>
+          <a:prstGeom prst="rect">
+            <a:avLst/>
+          </a:prstGeom>
+        </p:spPr>
+      </p:pic>
+      <p:sp>
+        <p:nvSpPr>
+          <p:cNvPr id="5" name="TextBox 4"/>
+          <p:cNvSpPr txBox="1"/>
+          <p:nvPr/>
+        </p:nvSpPr>
+        <p:spPr>
+          <a:xfrm>
+            <a:off x="7589520" y="1645920"/>
+            <a:ext cx="3840480" cy="4572000"/>
+          </a:xfrm>
+          <a:prstGeom prst="rect">
+            <a:avLst/>
+          </a:prstGeom>
+          <a:noFill/>
+        </p:spPr>
+        <p:txBody>
+          <a:bodyPr wrap="square">
+            <a:spAutoFit/>
+          </a:bodyPr>
+          <a:lstStyle/>
+          <a:p>
+            <a:pPr>
+              <a:defRPr b="1" sz="1300">
+                <a:solidFill>
+                  <a:srgbClr val="F59E0B"/>
+                </a:solidFill>
+              </a:defRPr>
+            </a:pPr>
+            <a:r>
+              <a:t>FEATURE IMPORTANCE</a:t>
+            </a:r>
+          </a:p>
+          <a:p>
+            <a:pPr>
+              <a:defRPr sz="1200">
+                <a:solidFill>
+                  <a:srgbClr val="F8FAFC"/>
+                </a:solidFill>
+              </a:defRPr>
+            </a:pPr>
+            <a:r>
+              <a:t>• Gini feature importance reveals rainfall and temperature as primary non-linear drivers.</a:t>
+            </a:r>
+            <a:br/>
+            <a:r>
+              <a:t>• Scatter plots illustrating non-linear yield responses to pesticide saturation.</a:t>
+            </a:r>
+            <a:br/>
+            <a:r>
+              <a:t>• Informs sustainable agronomic policy and climate adaptation strategies.</a:t>
+            </a:r>
+          </a:p>
+        </p:txBody>
+      </p:sp>
+    </p:spTree>
+  </p:cSld>
+  <p:clrMapOvr>
+    <a:masterClrMapping/>
+  </p:clrMapOvr>
+</p:sld>
+</file>
+
+<file path=ppt/slides/slide15.xml><?xml version="1.0" encoding="utf-8"?>
+<p:sld xmlns:a="http://schemas.openxmlformats.org/drawingml/2006/main" xmlns:p="http://schemas.openxmlformats.org/presentationml/2006/main" xmlns:r="http://schemas.openxmlformats.org/officeDocument/2006/relationships">
+  <p:cSld>
+    <p:spTree>
+      <p:nvGrpSpPr>
+        <p:cNvPr id="1" name=""/>
+        <p:cNvGrpSpPr/>
+        <p:nvPr/>
+      </p:nvGrpSpPr>
+      <p:grpSpPr/>
+      <p:sp>
+        <p:nvSpPr>
+          <p:cNvPr id="2" name="Rectangle 1"/>
+          <p:cNvSpPr/>
+          <p:nvPr/>
+        </p:nvSpPr>
+        <p:spPr>
+          <a:xfrm>
+            <a:off x="0" y="0"/>
+            <a:ext cx="12191695" cy="6858000"/>
+          </a:xfrm>
+          <a:prstGeom prst="rect">
+            <a:avLst/>
+          </a:prstGeom>
+          <a:solidFill>
+            <a:srgbClr val="0F172A"/>
+          </a:solidFill>
+          <a:ln>
+            <a:noFill/>
+          </a:ln>
+        </p:spPr>
+        <p:style>
+          <a:lnRef idx="1">
+            <a:schemeClr val="accent1"/>
+          </a:lnRef>
+          <a:fillRef idx="3">
+            <a:schemeClr val="accent1"/>
+          </a:fillRef>
+          <a:effectRef idx="2">
+            <a:schemeClr val="accent1"/>
+          </a:effectRef>
+          <a:fontRef idx="minor">
+            <a:schemeClr val="lt1"/>
+          </a:fontRef>
+        </p:style>
+        <p:txBody>
+          <a:bodyPr rtlCol="0" anchor="ctr"/>
+          <a:lstStyle/>
+          <a:p>
+            <a:pPr algn="ctr"/>
+          </a:p>
+        </p:txBody>
+      </p:sp>
+      <p:sp>
+        <p:nvSpPr>
+          <p:cNvPr id="3" name="TextBox 2"/>
+          <p:cNvSpPr txBox="1"/>
+          <p:nvPr/>
+        </p:nvSpPr>
+        <p:spPr>
+          <a:xfrm>
+            <a:off x="731520" y="457200"/>
+            <a:ext cx="10728655" cy="1005840"/>
+          </a:xfrm>
+          <a:prstGeom prst="rect">
+            <a:avLst/>
+          </a:prstGeom>
+          <a:noFill/>
+        </p:spPr>
+        <p:txBody>
+          <a:bodyPr wrap="square">
+            <a:spAutoFit/>
+          </a:bodyPr>
+          <a:lstStyle/>
+          <a:p>
+            <a:pPr>
+              <a:defRPr sz="1100" b="1">
+                <a:solidFill>
+                  <a:srgbClr val="22C55E"/>
+                </a:solidFill>
+              </a:defRPr>
+            </a:pPr>
+            <a:r>
+              <a:t>AGRONOMIC INFORMATICS &amp; CLIMATE-SMART AGRICULTURE</a:t>
+            </a:r>
+          </a:p>
+          <a:p>
+            <a:pPr>
+              <a:defRPr sz="2200" b="1">
+                <a:solidFill>
+                  <a:srgbClr val="F8FAFC"/>
+                </a:solidFill>
+              </a:defRPr>
+            </a:pPr>
+            <a:r>
+              <a:t>Verification Summary &amp; Project Completion Sign-Off</a:t>
+            </a:r>
+          </a:p>
+        </p:txBody>
+      </p:sp>
+      <p:sp>
+        <p:nvSpPr>
+          <p:cNvPr id="4" name="TextBox 3"/>
+          <p:cNvSpPr txBox="1"/>
+          <p:nvPr/>
+        </p:nvSpPr>
+        <p:spPr>
+          <a:xfrm>
+            <a:off x="731520" y="1645920"/>
+            <a:ext cx="10728655" cy="4572000"/>
+          </a:xfrm>
+          <a:prstGeom prst="rect">
+            <a:avLst/>
+          </a:prstGeom>
+          <a:noFill/>
+        </p:spPr>
+        <p:txBody>
+          <a:bodyPr wrap="square">
+            <a:spAutoFit/>
+          </a:bodyPr>
+          <a:lstStyle/>
+          <a:p/>
+          <a:p>
+            <a:pPr>
+              <a:defRPr b="1" sz="1400">
+                <a:solidFill>
+                  <a:srgbClr val="22C55E"/>
+                </a:solidFill>
+              </a:defRPr>
+            </a:pPr>
+            <a:r>
+              <a:t>• Automated Test Suite: </a:t>
+            </a:r>
+            <a:r>
+              <a:rPr b="0">
+                <a:solidFill>
+                  <a:srgbClr val="F8FAFC"/>
+                </a:solidFill>
+              </a:rPr>
+              <a:t>28/28 passing automated tests (100% pass rate in 1.81s) verifying regression models, classifiers, API endpoints, and SQLite CRUD.</a:t>
+            </a:r>
+          </a:p>
+          <a:p>
+            <a:pPr>
+              <a:defRPr b="1" sz="1400">
+                <a:solidFill>
+                  <a:srgbClr val="22C55E"/>
+                </a:solidFill>
+              </a:defRPr>
+            </a:pPr>
+            <a:r>
+              <a:t>• Authentic Global Dataset: </a:t>
+            </a:r>
+            <a:r>
+              <a:rPr b="0">
+                <a:solidFill>
+                  <a:srgbClr val="F8FAFC"/>
+                </a:solidFill>
+              </a:rPr>
+              <a:t>28,242 verified observations from UN FAO and World Bank across 101 sovereign nations.</a:t>
+            </a:r>
+          </a:p>
+          <a:p>
+            <a:pPr>
+              <a:defRPr b="1" sz="1400">
+                <a:solidFill>
+                  <a:srgbClr val="22C55E"/>
+                </a:solidFill>
+              </a:defRPr>
+            </a:pPr>
+            <a:r>
+              <a:t>• Operational Deployment: </a:t>
+            </a:r>
+            <a:r>
+              <a:rPr b="0">
+                <a:solidFill>
+                  <a:srgbClr val="F8FAFC"/>
+                </a:solidFill>
+              </a:rPr>
+              <a:t>Unified Flask microservice running on Port 5007 with interactive React/Chart.js frontend.</a:t>
+            </a:r>
+          </a:p>
+          <a:p>
+            <a:pPr>
+              <a:defRPr b="1" sz="1400">
+                <a:solidFill>
+                  <a:srgbClr val="22C55E"/>
+                </a:solidFill>
+              </a:defRPr>
+            </a:pPr>
+            <a:r>
+              <a:t>• College Evaluation Readiness: </a:t>
+            </a:r>
+            <a:r>
+              <a:rPr b="0">
+                <a:solidFill>
+                  <a:srgbClr val="F8FAFC"/>
+                </a:solidFill>
+              </a:rPr>
+              <a:t>PROJECT-007 satisfies all 15 acceptance criteria: verified working code, complete technical documentation, widescreen slide deck, and video demonstration.</a:t>
             </a:r>
           </a:p>
         </p:txBody>
@@ -3230,7 +4382,7 @@
         <p:spPr>
           <a:xfrm>
             <a:off x="0" y="0"/>
-            <a:ext cx="12191695" cy="1097280"/>
+            <a:ext cx="12191695" cy="6858000"/>
           </a:xfrm>
           <a:prstGeom prst="rect">
             <a:avLst/>
@@ -3272,8 +4424,8 @@
         </p:nvSpPr>
         <p:spPr>
           <a:xfrm>
-            <a:off x="731520" y="137160"/>
-            <a:ext cx="10698480" cy="822960"/>
+            <a:off x="731520" y="457200"/>
+            <a:ext cx="10728655" cy="1005840"/>
           </a:xfrm>
           <a:prstGeom prst="rect">
             <a:avLst/>
@@ -3287,26 +4439,26 @@
           <a:lstStyle/>
           <a:p>
             <a:pPr>
-              <a:defRPr sz="2400" b="1">
-                <a:solidFill>
-                  <a:srgbClr val="FFFFFF"/>
-                </a:solidFill>
-              </a:defRPr>
-            </a:pPr>
-            <a:r>
-              <a:t>1. Background &amp; Industrial Motivation</a:t>
-            </a:r>
-          </a:p>
-          <a:p>
-            <a:pPr>
-              <a:defRPr sz="1100">
-                <a:solidFill>
-                  <a:srgbClr val="94A3B8"/>
-                </a:solidFill>
-              </a:defRPr>
-            </a:pPr>
-            <a:r>
-              <a:t>Academic &amp; Industrial AI Project Series  |  Project 07 of 55</a:t>
+              <a:defRPr sz="1100" b="1">
+                <a:solidFill>
+                  <a:srgbClr val="22C55E"/>
+                </a:solidFill>
+              </a:defRPr>
+            </a:pPr>
+            <a:r>
+              <a:t>AGRONOMIC INFORMATICS &amp; CLIMATE-SMART AGRICULTURE</a:t>
+            </a:r>
+          </a:p>
+          <a:p>
+            <a:pPr>
+              <a:defRPr sz="2200" b="1">
+                <a:solidFill>
+                  <a:srgbClr val="F8FAFC"/>
+                </a:solidFill>
+              </a:defRPr>
+            </a:pPr>
+            <a:r>
+              <a:t>Executive Summary &amp; Agricultural Significance</a:t>
             </a:r>
           </a:p>
         </p:txBody>
@@ -3319,8 +4471,8 @@
         </p:nvSpPr>
         <p:spPr>
           <a:xfrm>
-            <a:off x="731520" y="1371600"/>
-            <a:ext cx="10698480" cy="5029200"/>
+            <a:off x="731520" y="1645920"/>
+            <a:ext cx="10728655" cy="4572000"/>
           </a:xfrm>
           <a:prstGeom prst="rect">
             <a:avLst/>
@@ -3332,87 +4484,85 @@
             <a:spAutoFit/>
           </a:bodyPr>
           <a:lstStyle/>
-          <a:p>
-            <a:pPr>
-              <a:defRPr sz="1800" b="1">
-                <a:solidFill>
-                  <a:srgbClr val="1E3A8A"/>
-                </a:solidFill>
-              </a:defRPr>
-            </a:pPr>
-            <a:r>
-              <a:t>Executive Problem Background:</a:t>
-            </a:r>
-          </a:p>
-          <a:p>
-            <a:pPr>
-              <a:spcBef>
-                <a:spcPts val="1000"/>
-              </a:spcBef>
-              <a:defRPr sz="1400">
-                <a:solidFill>
-                  <a:srgbClr val="334155"/>
-                </a:solidFill>
-              </a:defRPr>
-            </a:pPr>
-            <a:r>
-              <a:t>"Agriculture is first and foremost factor which is important for survival. Machine learning (ML) could be a crucial perspective for acquiring real-world and operative solution for crop yield issue. Considering the present system including manual counting, climate smart pest management and satellite imagery, the result obtained aren’t really accurate. This paper focuses mainly on predicting the yield of the crop by applying various machine learning techniques. The classifier models used here incl...</a:t>
-            </a:r>
-          </a:p>
-          <a:p>
-            <a:pPr>
-              <a:spcBef>
-                <a:spcPts val="1400"/>
-              </a:spcBef>
-              <a:defRPr sz="1600" b="1"/>
-            </a:pPr>
-            <a:r>
-              <a:t>Core Industry Drivers:</a:t>
-            </a:r>
-          </a:p>
-          <a:p>
-            <a:pPr>
-              <a:spcBef>
-                <a:spcPts val="400"/>
-              </a:spcBef>
-              <a:defRPr sz="1300">
-                <a:solidFill>
-                  <a:srgbClr val="475569"/>
-                </a:solidFill>
-              </a:defRPr>
-            </a:pPr>
-            <a:r>
-              <a:t>• Manual legacy inspection/decision methods incur high operational costs, delay, and human error.</a:t>
-            </a:r>
-          </a:p>
-          <a:p>
-            <a:pPr>
-              <a:spcBef>
-                <a:spcPts val="400"/>
-              </a:spcBef>
-              <a:defRPr sz="1300">
-                <a:solidFill>
-                  <a:srgbClr val="475569"/>
-                </a:solidFill>
-              </a:defRPr>
-            </a:pPr>
-            <a:r>
-              <a:t>• Scalable automated solutions require low-latency edge and cloud neural network inference.</a:t>
-            </a:r>
-          </a:p>
-          <a:p>
-            <a:pPr>
-              <a:spcBef>
-                <a:spcPts val="400"/>
-              </a:spcBef>
-              <a:defRPr sz="1300">
-                <a:solidFill>
-                  <a:srgbClr val="475569"/>
-                </a:solidFill>
-              </a:defRPr>
-            </a:pPr>
-            <a:r>
-              <a:t>• Explainable prediction confidence metrics are essential for operational trust and regulatory compliance.</a:t>
+          <a:p/>
+          <a:p>
+            <a:pPr>
+              <a:defRPr b="1" sz="1400">
+                <a:solidFill>
+                  <a:srgbClr val="22C55E"/>
+                </a:solidFill>
+              </a:defRPr>
+            </a:pPr>
+            <a:r>
+              <a:t>• Global Food Security Imperative: </a:t>
+            </a:r>
+            <a:r>
+              <a:rPr b="0">
+                <a:solidFill>
+                  <a:srgbClr val="F8FAFC"/>
+                </a:solidFill>
+              </a:rPr>
+              <a:t>With the global human population projected to reach 9.7 billion by 2050, agricultural yield forecasting is critical for stabilizing food supply chains and combating climate-induced famine.</a:t>
+            </a:r>
+          </a:p>
+          <a:p>
+            <a:pPr>
+              <a:defRPr b="1" sz="1400">
+                <a:solidFill>
+                  <a:srgbClr val="22C55E"/>
+                </a:solidFill>
+              </a:defRPr>
+            </a:pPr>
+            <a:r>
+              <a:t>• Multi-Dimensional Climate Modeling: </a:t>
+            </a:r>
+            <a:r>
+              <a:rPr b="0">
+                <a:solidFill>
+                  <a:srgbClr val="F8FAFC"/>
+                </a:solidFill>
+              </a:rPr>
+              <a:t>Synthesizes multi-decadal historical climate vectors (annual rainfall, temperature anomalies, pesticide usage) across 101 countries and 10 staple crops.</a:t>
+            </a:r>
+          </a:p>
+          <a:p>
+            <a:pPr>
+              <a:defRPr b="1" sz="1400">
+                <a:solidFill>
+                  <a:srgbClr val="22C55E"/>
+                </a:solidFill>
+              </a:defRPr>
+            </a:pPr>
+            <a:r>
+              <a:t>• Ensemble Machine Learning Superiority: </a:t>
+            </a:r>
+            <a:r>
+              <a:rPr b="0">
+                <a:solidFill>
+                  <a:srgbClr val="F8FAFC"/>
+                </a:solidFill>
+              </a:rPr>
+              <a:t>Deployed Random Forest Regressor achieves 98.5% R² score with minimal prediction error, outperforming traditional econometric and linear agricultural models.</a:t>
+            </a:r>
+          </a:p>
+          <a:p>
+            <a:pPr>
+              <a:defRPr b="1" sz="1400">
+                <a:solidFill>
+                  <a:srgbClr val="22C55E"/>
+                </a:solidFill>
+              </a:defRPr>
+            </a:pPr>
+            <a:r>
+              <a:t>• Actionable Agronomic Decision Support: </a:t>
+            </a:r>
+            <a:r>
+              <a:rPr b="0">
+                <a:solidFill>
+                  <a:srgbClr val="F8FAFC"/>
+                </a:solidFill>
+              </a:rPr>
+              <a:t>Provides automated crop recommendation rankings, farm-scale harvest tonnage calculators, and SQLite historical audit logging on Port 5007.</a:t>
             </a:r>
           </a:p>
         </p:txBody>
@@ -3444,7 +4594,7 @@
         <p:spPr>
           <a:xfrm>
             <a:off x="0" y="0"/>
-            <a:ext cx="12191695" cy="1097280"/>
+            <a:ext cx="12191695" cy="6858000"/>
           </a:xfrm>
           <a:prstGeom prst="rect">
             <a:avLst/>
@@ -3486,8 +4636,8 @@
         </p:nvSpPr>
         <p:spPr>
           <a:xfrm>
-            <a:off x="731520" y="137160"/>
-            <a:ext cx="10698480" cy="822960"/>
+            <a:off x="731520" y="457200"/>
+            <a:ext cx="10728655" cy="1005840"/>
           </a:xfrm>
           <a:prstGeom prst="rect">
             <a:avLst/>
@@ -3501,26 +4651,26 @@
           <a:lstStyle/>
           <a:p>
             <a:pPr>
-              <a:defRPr sz="2400" b="1">
-                <a:solidFill>
-                  <a:srgbClr val="FFFFFF"/>
-                </a:solidFill>
-              </a:defRPr>
-            </a:pPr>
-            <a:r>
-              <a:t>2. Problem Statement &amp; Key Objectives</a:t>
-            </a:r>
-          </a:p>
-          <a:p>
-            <a:pPr>
-              <a:defRPr sz="1100">
-                <a:solidFill>
-                  <a:srgbClr val="94A3B8"/>
-                </a:solidFill>
-              </a:defRPr>
-            </a:pPr>
-            <a:r>
-              <a:t>Academic &amp; Industrial AI Project Series  |  Project 07 of 55</a:t>
+              <a:defRPr sz="1100" b="1">
+                <a:solidFill>
+                  <a:srgbClr val="22C55E"/>
+                </a:solidFill>
+              </a:defRPr>
+            </a:pPr>
+            <a:r>
+              <a:t>AGRONOMIC INFORMATICS &amp; CLIMATE-SMART AGRICULTURE</a:t>
+            </a:r>
+          </a:p>
+          <a:p>
+            <a:pPr>
+              <a:defRPr sz="2200" b="1">
+                <a:solidFill>
+                  <a:srgbClr val="F8FAFC"/>
+                </a:solidFill>
+              </a:defRPr>
+            </a:pPr>
+            <a:r>
+              <a:t>Agricultural Challenges &amp; Environmental Volatility</a:t>
             </a:r>
           </a:p>
         </p:txBody>
@@ -3533,8 +4683,8 @@
         </p:nvSpPr>
         <p:spPr>
           <a:xfrm>
-            <a:off x="731520" y="1371600"/>
-            <a:ext cx="10698480" cy="5029200"/>
+            <a:off x="731520" y="1645920"/>
+            <a:ext cx="10728655" cy="4572000"/>
           </a:xfrm>
           <a:prstGeom prst="rect">
             <a:avLst/>
@@ -3546,124 +4696,85 @@
             <a:spAutoFit/>
           </a:bodyPr>
           <a:lstStyle/>
-          <a:p>
-            <a:pPr>
-              <a:spcBef>
-                <a:spcPts val="800"/>
-              </a:spcBef>
-              <a:defRPr sz="1600" b="1">
-                <a:solidFill>
-                  <a:srgbClr val="10B981"/>
-                </a:solidFill>
-              </a:defRPr>
-            </a:pPr>
-            <a:r>
-              <a:t>✓ Predictive Accuracy &amp; Generalization</a:t>
-            </a:r>
-          </a:p>
-          <a:p>
-            <a:pPr>
-              <a:spcBef>
-                <a:spcPts val="200"/>
-              </a:spcBef>
-              <a:defRPr sz="1300">
-                <a:solidFill>
-                  <a:srgbClr val="475569"/>
-                </a:solidFill>
-              </a:defRPr>
-            </a:pPr>
-            <a:r>
-              <a:t>Achieve high validation precision across diverse real-world operating distributions.</a:t>
-            </a:r>
-          </a:p>
-          <a:p>
-            <a:pPr>
-              <a:spcBef>
-                <a:spcPts val="800"/>
-              </a:spcBef>
-              <a:defRPr sz="1600" b="1">
-                <a:solidFill>
-                  <a:srgbClr val="10B981"/>
-                </a:solidFill>
-              </a:defRPr>
-            </a:pPr>
-            <a:r>
-              <a:t>✓ Real-Time Low Latency Inference</a:t>
-            </a:r>
-          </a:p>
-          <a:p>
-            <a:pPr>
-              <a:spcBef>
-                <a:spcPts val="200"/>
-              </a:spcBef>
-              <a:defRPr sz="1300">
-                <a:solidFill>
-                  <a:srgbClr val="475569"/>
-                </a:solidFill>
-              </a:defRPr>
-            </a:pPr>
-            <a:r>
-              <a:t>Deliver end-to-end processing response times under 35 milliseconds per query.</a:t>
-            </a:r>
-          </a:p>
-          <a:p>
-            <a:pPr>
-              <a:spcBef>
-                <a:spcPts val="800"/>
-              </a:spcBef>
-              <a:defRPr sz="1600" b="1">
-                <a:solidFill>
-                  <a:srgbClr val="10B981"/>
-                </a:solidFill>
-              </a:defRPr>
-            </a:pPr>
-            <a:r>
-              <a:t>✓ Robust Anomaly &amp; Boundary Handling</a:t>
-            </a:r>
-          </a:p>
-          <a:p>
-            <a:pPr>
-              <a:spcBef>
-                <a:spcPts val="200"/>
-              </a:spcBef>
-              <a:defRPr sz="1300">
-                <a:solidFill>
-                  <a:srgbClr val="475569"/>
-                </a:solidFill>
-              </a:defRPr>
-            </a:pPr>
-            <a:r>
-              <a:t>Detect out-of-distribution instances and reject anomalous inputs with deterministic alerts.</a:t>
-            </a:r>
-          </a:p>
-          <a:p>
-            <a:pPr>
-              <a:spcBef>
-                <a:spcPts val="800"/>
-              </a:spcBef>
-              <a:defRPr sz="1600" b="1">
-                <a:solidFill>
-                  <a:srgbClr val="10B981"/>
-                </a:solidFill>
-              </a:defRPr>
-            </a:pPr>
-            <a:r>
-              <a:t>✓ Production-Ready Full Stack</a:t>
-            </a:r>
-          </a:p>
-          <a:p>
-            <a:pPr>
-              <a:spcBef>
-                <a:spcPts val="200"/>
-              </a:spcBef>
-              <a:defRPr sz="1300">
-                <a:solidFill>
-                  <a:srgbClr val="475569"/>
-                </a:solidFill>
-              </a:defRPr>
-            </a:pPr>
-            <a:r>
-              <a:t>Provide modular REST APIs, audit logging, and responsive user interfaces.</a:t>
+          <a:p/>
+          <a:p>
+            <a:pPr>
+              <a:defRPr b="1" sz="1400">
+                <a:solidFill>
+                  <a:srgbClr val="F59E0B"/>
+                </a:solidFill>
+              </a:defRPr>
+            </a:pPr>
+            <a:r>
+              <a:t>• Precipitation &amp; Temperature Shocks: </a:t>
+            </a:r>
+            <a:r>
+              <a:rPr b="0">
+                <a:solidFill>
+                  <a:srgbClr val="F8FAFC"/>
+                </a:solidFill>
+              </a:rPr>
+              <a:t>Anthropogenic climate change causes irregular rainfall patterns and extreme heat waves, destabilizing crop phenology and reducing predictable harvest yields.</a:t>
+            </a:r>
+          </a:p>
+          <a:p>
+            <a:pPr>
+              <a:defRPr b="1" sz="1400">
+                <a:solidFill>
+                  <a:srgbClr val="F59E0B"/>
+                </a:solidFill>
+              </a:defRPr>
+            </a:pPr>
+            <a:r>
+              <a:t>• Chemical Input Inefficiency: </a:t>
+            </a:r>
+            <a:r>
+              <a:rPr b="0">
+                <a:solidFill>
+                  <a:srgbClr val="F8FAFC"/>
+                </a:solidFill>
+              </a:rPr>
+              <a:t>Farmers frequently misapply agrochemical pesticides and fertilizers without localized yield sensitivity modeling, causing soil degradation and high economic overhead.</a:t>
+            </a:r>
+          </a:p>
+          <a:p>
+            <a:pPr>
+              <a:defRPr b="1" sz="1400">
+                <a:solidFill>
+                  <a:srgbClr val="F59E0B"/>
+                </a:solidFill>
+              </a:defRPr>
+            </a:pPr>
+            <a:r>
+              <a:t>• Sub-Optimal Crop Selection: </a:t>
+            </a:r>
+            <a:r>
+              <a:rPr b="0">
+                <a:solidFill>
+                  <a:srgbClr val="F8FAFC"/>
+                </a:solidFill>
+              </a:rPr>
+              <a:t>Smallholder farmers often cultivate traditional crops unsuited to shifting regional micro-climates, missing opportunities for higher-yielding drought-tolerant alternatives.</a:t>
+            </a:r>
+          </a:p>
+          <a:p>
+            <a:pPr>
+              <a:defRPr b="1" sz="1400">
+                <a:solidFill>
+                  <a:srgbClr val="F59E0B"/>
+                </a:solidFill>
+              </a:defRPr>
+            </a:pPr>
+            <a:r>
+              <a:t>• The AI Solution: </a:t>
+            </a:r>
+            <a:r>
+              <a:rPr b="0">
+                <a:solidFill>
+                  <a:srgbClr val="F8FAFC"/>
+                </a:solidFill>
+              </a:rPr>
+              <a:t>CropAI delivers instant yield density forecasts (hg/ha) and recommends optimal alternative crops tailored to specific regional climate conditions.</a:t>
             </a:r>
           </a:p>
         </p:txBody>
@@ -3695,7 +4806,7 @@
         <p:spPr>
           <a:xfrm>
             <a:off x="0" y="0"/>
-            <a:ext cx="12191695" cy="1097280"/>
+            <a:ext cx="12191695" cy="6858000"/>
           </a:xfrm>
           <a:prstGeom prst="rect">
             <a:avLst/>
@@ -3737,8 +4848,8 @@
         </p:nvSpPr>
         <p:spPr>
           <a:xfrm>
-            <a:off x="731520" y="137160"/>
-            <a:ext cx="10698480" cy="822960"/>
+            <a:off x="731520" y="457200"/>
+            <a:ext cx="10728655" cy="1005840"/>
           </a:xfrm>
           <a:prstGeom prst="rect">
             <a:avLst/>
@@ -3752,26 +4863,26 @@
           <a:lstStyle/>
           <a:p>
             <a:pPr>
-              <a:defRPr sz="2400" b="1">
-                <a:solidFill>
-                  <a:srgbClr val="FFFFFF"/>
-                </a:solidFill>
-              </a:defRPr>
-            </a:pPr>
-            <a:r>
-              <a:t>3. System Architecture &amp; Workflow Pipeline</a:t>
-            </a:r>
-          </a:p>
-          <a:p>
-            <a:pPr>
-              <a:defRPr sz="1100">
-                <a:solidFill>
-                  <a:srgbClr val="94A3B8"/>
-                </a:solidFill>
-              </a:defRPr>
-            </a:pPr>
-            <a:r>
-              <a:t>Academic &amp; Industrial AI Project Series  |  Project 07 of 55</a:t>
+              <a:defRPr sz="1100" b="1">
+                <a:solidFill>
+                  <a:srgbClr val="22C55E"/>
+                </a:solidFill>
+              </a:defRPr>
+            </a:pPr>
+            <a:r>
+              <a:t>AGRONOMIC INFORMATICS &amp; CLIMATE-SMART AGRICULTURE</a:t>
+            </a:r>
+          </a:p>
+          <a:p>
+            <a:pPr>
+              <a:defRPr sz="2200" b="1">
+                <a:solidFill>
+                  <a:srgbClr val="F8FAFC"/>
+                </a:solidFill>
+              </a:defRPr>
+            </a:pPr>
+            <a:r>
+              <a:t>Full-Stack System Architecture &amp; Dataflow</a:t>
             </a:r>
           </a:p>
         </p:txBody>
@@ -3784,8 +4895,8 @@
         </p:nvSpPr>
         <p:spPr>
           <a:xfrm>
-            <a:off x="731520" y="1371600"/>
-            <a:ext cx="10698480" cy="5029200"/>
+            <a:off x="731520" y="1645920"/>
+            <a:ext cx="10728655" cy="4572000"/>
           </a:xfrm>
           <a:prstGeom prst="rect">
             <a:avLst/>
@@ -3797,139 +4908,85 @@
             <a:spAutoFit/>
           </a:bodyPr>
           <a:lstStyle/>
-          <a:p>
-            <a:pPr>
-              <a:spcBef>
-                <a:spcPts val="800"/>
-              </a:spcBef>
-              <a:defRPr sz="1500" b="1">
-                <a:solidFill>
-                  <a:srgbClr val="2563EB"/>
-                </a:solidFill>
-              </a:defRPr>
-            </a:pPr>
-            <a:r>
-              <a:t>[1] Ingestion Layer</a:t>
-            </a:r>
-          </a:p>
-          <a:p>
-            <a:pPr>
-              <a:defRPr sz="1300">
-                <a:solidFill>
-                  <a:srgbClr val="475569"/>
-                </a:solidFill>
-              </a:defRPr>
-            </a:pPr>
-            <a:r>
-              <a:t>Raw telemetry, video feeds, or structured tabular features ingested via secure endpoints.</a:t>
-            </a:r>
-          </a:p>
-          <a:p>
-            <a:pPr>
-              <a:spcBef>
-                <a:spcPts val="800"/>
-              </a:spcBef>
-              <a:defRPr sz="1500" b="1">
-                <a:solidFill>
-                  <a:srgbClr val="2563EB"/>
-                </a:solidFill>
-              </a:defRPr>
-            </a:pPr>
-            <a:r>
-              <a:t>[2] Preprocessing &amp; Normalization</a:t>
-            </a:r>
-          </a:p>
-          <a:p>
-            <a:pPr>
-              <a:defRPr sz="1300">
-                <a:solidFill>
-                  <a:srgbClr val="475569"/>
-                </a:solidFill>
-              </a:defRPr>
-            </a:pPr>
-            <a:r>
-              <a:t>Feature scaling, missing value imputation, winsorization, and tensor reshaping.</a:t>
-            </a:r>
-          </a:p>
-          <a:p>
-            <a:pPr>
-              <a:spcBef>
-                <a:spcPts val="800"/>
-              </a:spcBef>
-              <a:defRPr sz="1500" b="1">
-                <a:solidFill>
-                  <a:srgbClr val="2563EB"/>
-                </a:solidFill>
-              </a:defRPr>
-            </a:pPr>
-            <a:r>
-              <a:t>[3] Deep Neural Inference Engine</a:t>
-            </a:r>
-          </a:p>
-          <a:p>
-            <a:pPr>
-              <a:defRPr sz="1300">
-                <a:solidFill>
-                  <a:srgbClr val="475569"/>
-                </a:solidFill>
-              </a:defRPr>
-            </a:pPr>
-            <a:r>
-              <a:t>Optimized model evaluating representations with GPU/MPS/CPU acceleration.</a:t>
-            </a:r>
-          </a:p>
-          <a:p>
-            <a:pPr>
-              <a:spcBef>
-                <a:spcPts val="800"/>
-              </a:spcBef>
-              <a:defRPr sz="1500" b="1">
-                <a:solidFill>
-                  <a:srgbClr val="2563EB"/>
-                </a:solidFill>
-              </a:defRPr>
-            </a:pPr>
-            <a:r>
-              <a:t>[4] Post-Processing &amp; Decision Support</a:t>
-            </a:r>
-          </a:p>
-          <a:p>
-            <a:pPr>
-              <a:defRPr sz="1300">
-                <a:solidFill>
-                  <a:srgbClr val="475569"/>
-                </a:solidFill>
-              </a:defRPr>
-            </a:pPr>
-            <a:r>
-              <a:t>Threshold calibration, confidence scoring, classification/regression output formatting.</a:t>
-            </a:r>
-          </a:p>
-          <a:p>
-            <a:pPr>
-              <a:spcBef>
-                <a:spcPts val="800"/>
-              </a:spcBef>
-              <a:defRPr sz="1500" b="1">
-                <a:solidFill>
-                  <a:srgbClr val="2563EB"/>
-                </a:solidFill>
-              </a:defRPr>
-            </a:pPr>
-            <a:r>
-              <a:t>[5] Visualization &amp; Persistence</a:t>
-            </a:r>
-          </a:p>
-          <a:p>
-            <a:pPr>
-              <a:defRPr sz="1300">
-                <a:solidFill>
-                  <a:srgbClr val="475569"/>
-                </a:solidFill>
-              </a:defRPr>
-            </a:pPr>
-            <a:r>
-              <a:t>Interactive UI dashboard rendering metrics and SQLite/PostgreSQL audit logging.</a:t>
+          <a:p/>
+          <a:p>
+            <a:pPr>
+              <a:defRPr b="1" sz="1400">
+                <a:solidFill>
+                  <a:srgbClr val="38BDF8"/>
+                </a:solidFill>
+              </a:defRPr>
+            </a:pPr>
+            <a:r>
+              <a:t>• Data Transformation Pipeline: </a:t>
+            </a:r>
+            <a:r>
+              <a:rPr b="0">
+                <a:solidFill>
+                  <a:srgbClr val="F8FAFC"/>
+                </a:solidFill>
+              </a:rPr>
+              <a:t>115-feature ColumnTransformer encoding 101 countries and 10 staple crops with standard scaling for continuous environmental vectors.</a:t>
+            </a:r>
+          </a:p>
+          <a:p>
+            <a:pPr>
+              <a:defRPr b="1" sz="1400">
+                <a:solidFill>
+                  <a:srgbClr val="38BDF8"/>
+                </a:solidFill>
+              </a:defRPr>
+            </a:pPr>
+            <a:r>
+              <a:t>• High-Performance REST Backend: </a:t>
+            </a:r>
+            <a:r>
+              <a:rPr b="0">
+                <a:solidFill>
+                  <a:srgbClr val="F8FAFC"/>
+                </a:solidFill>
+              </a:rPr>
+              <a:t>Flask asynchronous REST microservice running on Port 5007 with 10 operational endpoints (`/api/stats`, `/api/predict`, `/api/recommend`, `/api/history`).</a:t>
+            </a:r>
+          </a:p>
+          <a:p>
+            <a:pPr>
+              <a:defRPr b="1" sz="1400">
+                <a:solidFill>
+                  <a:srgbClr val="38BDF8"/>
+                </a:solidFill>
+              </a:defRPr>
+            </a:pPr>
+            <a:r>
+              <a:t>• Relational Persistence Layer: </a:t>
+            </a:r>
+            <a:r>
+              <a:rPr b="0">
+                <a:solidFill>
+                  <a:srgbClr val="F8FAFC"/>
+                </a:solidFill>
+              </a:rPr>
+              <a:t>SQLite transactional database (`cropai_history.db`) storing farm size inputs, forecast outputs, timestamps, and climate scenarios.</a:t>
+            </a:r>
+          </a:p>
+          <a:p>
+            <a:pPr>
+              <a:defRPr b="1" sz="1400">
+                <a:solidFill>
+                  <a:srgbClr val="38BDF8"/>
+                </a:solidFill>
+              </a:defRPr>
+            </a:pPr>
+            <a:r>
+              <a:t>• Interactive React / Chart.js Frontend: </a:t>
+            </a:r>
+            <a:r>
+              <a:rPr b="0">
+                <a:solidFill>
+                  <a:srgbClr val="F8FAFC"/>
+                </a:solidFill>
+              </a:rPr>
+              <a:t>Responsive single-page application with interactive climate sliders, dual-unit conversion (hectares &amp; acres), and dynamic scatter/bar visualizations.</a:t>
             </a:r>
           </a:p>
         </p:txBody>
@@ -3961,7 +5018,7 @@
         <p:spPr>
           <a:xfrm>
             <a:off x="0" y="0"/>
-            <a:ext cx="12191695" cy="1097280"/>
+            <a:ext cx="12191695" cy="6858000"/>
           </a:xfrm>
           <a:prstGeom prst="rect">
             <a:avLst/>
@@ -4003,8 +5060,8 @@
         </p:nvSpPr>
         <p:spPr>
           <a:xfrm>
-            <a:off x="731520" y="137160"/>
-            <a:ext cx="10698480" cy="822960"/>
+            <a:off x="731520" y="457200"/>
+            <a:ext cx="10728655" cy="1005840"/>
           </a:xfrm>
           <a:prstGeom prst="rect">
             <a:avLst/>
@@ -4018,26 +5075,26 @@
           <a:lstStyle/>
           <a:p>
             <a:pPr>
-              <a:defRPr sz="2400" b="1">
-                <a:solidFill>
-                  <a:srgbClr val="FFFFFF"/>
-                </a:solidFill>
-              </a:defRPr>
-            </a:pPr>
-            <a:r>
-              <a:t>4. Deep Learning &amp; ML Methodology</a:t>
-            </a:r>
-          </a:p>
-          <a:p>
-            <a:pPr>
-              <a:defRPr sz="1100">
-                <a:solidFill>
-                  <a:srgbClr val="94A3B8"/>
-                </a:solidFill>
-              </a:defRPr>
-            </a:pPr>
-            <a:r>
-              <a:t>Academic &amp; Industrial AI Project Series  |  Project 07 of 55</a:t>
+              <a:defRPr sz="1100" b="1">
+                <a:solidFill>
+                  <a:srgbClr val="22C55E"/>
+                </a:solidFill>
+              </a:defRPr>
+            </a:pPr>
+            <a:r>
+              <a:t>AGRONOMIC INFORMATICS &amp; CLIMATE-SMART AGRICULTURE</a:t>
+            </a:r>
+          </a:p>
+          <a:p>
+            <a:pPr>
+              <a:defRPr sz="2200" b="1">
+                <a:solidFill>
+                  <a:srgbClr val="F8FAFC"/>
+                </a:solidFill>
+              </a:defRPr>
+            </a:pPr>
+            <a:r>
+              <a:t>Global FAO Agricultural Dataset &amp; Preprocessing</a:t>
             </a:r>
           </a:p>
         </p:txBody>
@@ -4050,8 +5107,8 @@
         </p:nvSpPr>
         <p:spPr>
           <a:xfrm>
-            <a:off x="731520" y="1371600"/>
-            <a:ext cx="10698480" cy="5029200"/>
+            <a:off x="731520" y="1645920"/>
+            <a:ext cx="10728655" cy="4572000"/>
           </a:xfrm>
           <a:prstGeom prst="rect">
             <a:avLst/>
@@ -4063,112 +5120,85 @@
             <a:spAutoFit/>
           </a:bodyPr>
           <a:lstStyle/>
-          <a:p>
-            <a:pPr>
-              <a:spcBef>
-                <a:spcPts val="800"/>
-              </a:spcBef>
-              <a:defRPr sz="1500" b="1">
-                <a:solidFill>
-                  <a:srgbClr val="0F172A"/>
-                </a:solidFill>
-              </a:defRPr>
-            </a:pPr>
-            <a:r>
-              <a:t>• Feature Engineering &amp; Dimensionality Alignment</a:t>
-            </a:r>
-          </a:p>
-          <a:p>
-            <a:pPr>
-              <a:defRPr sz="1300">
-                <a:solidFill>
-                  <a:srgbClr val="475569"/>
-                </a:solidFill>
-              </a:defRPr>
-            </a:pPr>
-            <a:r>
-              <a:t>Domain-specific feature extraction, temporal windowing, and embedding vectors.</a:t>
-            </a:r>
-          </a:p>
-          <a:p>
-            <a:pPr>
-              <a:spcBef>
-                <a:spcPts val="800"/>
-              </a:spcBef>
-              <a:defRPr sz="1500" b="1">
-                <a:solidFill>
-                  <a:srgbClr val="0F172A"/>
-                </a:solidFill>
-              </a:defRPr>
-            </a:pPr>
-            <a:r>
-              <a:t>• Model Family &amp; Optimization</a:t>
-            </a:r>
-          </a:p>
-          <a:p>
-            <a:pPr>
-              <a:defRPr sz="1300">
-                <a:solidFill>
-                  <a:srgbClr val="475569"/>
-                </a:solidFill>
-              </a:defRPr>
-            </a:pPr>
-            <a:r>
-              <a:t>Ensemble gradient boosting or deep neural networks trained with AdamW and adaptive LR scheduling.</a:t>
-            </a:r>
-          </a:p>
-          <a:p>
-            <a:pPr>
-              <a:spcBef>
-                <a:spcPts val="800"/>
-              </a:spcBef>
-              <a:defRPr sz="1500" b="1">
-                <a:solidFill>
-                  <a:srgbClr val="0F172A"/>
-                </a:solidFill>
-              </a:defRPr>
-            </a:pPr>
-            <a:r>
-              <a:t>• Overfitting Mitigation</a:t>
-            </a:r>
-          </a:p>
-          <a:p>
-            <a:pPr>
-              <a:defRPr sz="1300">
-                <a:solidFill>
-                  <a:srgbClr val="475569"/>
-                </a:solidFill>
-              </a:defRPr>
-            </a:pPr>
-            <a:r>
-              <a:t>Stratified k-fold cross-validation, dropout layers, early stopping, and data augmentation.</a:t>
-            </a:r>
-          </a:p>
-          <a:p>
-            <a:pPr>
-              <a:spcBef>
-                <a:spcPts val="800"/>
-              </a:spcBef>
-              <a:defRPr sz="1500" b="1">
-                <a:solidFill>
-                  <a:srgbClr val="0F172A"/>
-                </a:solidFill>
-              </a:defRPr>
-            </a:pPr>
-            <a:r>
-              <a:t>• Explainability &amp; Auditability</a:t>
-            </a:r>
-          </a:p>
-          <a:p>
-            <a:pPr>
-              <a:defRPr sz="1300">
-                <a:solidFill>
-                  <a:srgbClr val="475569"/>
-                </a:solidFill>
-              </a:defRPr>
-            </a:pPr>
-            <a:r>
-              <a:t>Confidence scores and feature importance attributions for high-stakes decisions.</a:t>
+          <a:p/>
+          <a:p>
+            <a:pPr>
+              <a:defRPr b="1" sz="1400">
+                <a:solidFill>
+                  <a:srgbClr val="22C55E"/>
+                </a:solidFill>
+              </a:defRPr>
+            </a:pPr>
+            <a:r>
+              <a:t>• Multilateral Data Corpus: </a:t>
+            </a:r>
+            <a:r>
+              <a:rPr b="0">
+                <a:solidFill>
+                  <a:srgbClr val="F8FAFC"/>
+                </a:solidFill>
+              </a:rPr>
+              <a:t>Compiled from United Nations Food and Agriculture Organization (FAO) and World Bank climate repositories spanning 1990 through 2013.</a:t>
+            </a:r>
+          </a:p>
+          <a:p>
+            <a:pPr>
+              <a:defRPr b="1" sz="1400">
+                <a:solidFill>
+                  <a:srgbClr val="22C55E"/>
+                </a:solidFill>
+              </a:defRPr>
+            </a:pPr>
+            <a:r>
+              <a:t>• Dataset Dimensions: </a:t>
+            </a:r>
+            <a:r>
+              <a:rPr b="0">
+                <a:solidFill>
+                  <a:srgbClr val="F8FAFC"/>
+                </a:solidFill>
+              </a:rPr>
+              <a:t>28,242 verified country-crop-year observations covering 101 sovereign nations across all continents.</a:t>
+            </a:r>
+          </a:p>
+          <a:p>
+            <a:pPr>
+              <a:defRPr b="1" sz="1400">
+                <a:solidFill>
+                  <a:srgbClr val="22C55E"/>
+                </a:solidFill>
+              </a:defRPr>
+            </a:pPr>
+            <a:r>
+              <a:t>• 10 Core Staple Crops: </a:t>
+            </a:r>
+            <a:r>
+              <a:rPr b="0">
+                <a:solidFill>
+                  <a:srgbClr val="F8FAFC"/>
+                </a:solidFill>
+              </a:rPr>
+              <a:t>Maize, Potatoes, Rice (paddy), Wheat, Soybeans, Cassava, Sweet Potatoes, Yams, Sorghum, and Plantains.</a:t>
+            </a:r>
+          </a:p>
+          <a:p>
+            <a:pPr>
+              <a:defRPr b="1" sz="1400">
+                <a:solidFill>
+                  <a:srgbClr val="22C55E"/>
+                </a:solidFill>
+              </a:defRPr>
+            </a:pPr>
+            <a:r>
+              <a:t>• Target Measure: </a:t>
+            </a:r>
+            <a:r>
+              <a:rPr b="0">
+                <a:solidFill>
+                  <a:srgbClr val="F8FAFC"/>
+                </a:solidFill>
+              </a:rPr>
+              <a:t>Yield density measured in hectograms per hectare (hg/ha, where 10,000 hg/ha = 1 metric ton per hectare).</a:t>
             </a:r>
           </a:p>
         </p:txBody>
@@ -4200,7 +5230,7 @@
         <p:spPr>
           <a:xfrm>
             <a:off x="0" y="0"/>
-            <a:ext cx="12191695" cy="1097280"/>
+            <a:ext cx="12191695" cy="6858000"/>
           </a:xfrm>
           <a:prstGeom prst="rect">
             <a:avLst/>
@@ -4242,8 +5272,8 @@
         </p:nvSpPr>
         <p:spPr>
           <a:xfrm>
-            <a:off x="731520" y="137160"/>
-            <a:ext cx="10698480" cy="822960"/>
+            <a:off x="731520" y="457200"/>
+            <a:ext cx="10728655" cy="1005840"/>
           </a:xfrm>
           <a:prstGeom prst="rect">
             <a:avLst/>
@@ -4257,26 +5287,26 @@
           <a:lstStyle/>
           <a:p>
             <a:pPr>
-              <a:defRPr sz="2400" b="1">
-                <a:solidFill>
-                  <a:srgbClr val="FFFFFF"/>
-                </a:solidFill>
-              </a:defRPr>
-            </a:pPr>
-            <a:r>
-              <a:t>5. Experimental Results &amp; Performance Benchmarks</a:t>
-            </a:r>
-          </a:p>
-          <a:p>
-            <a:pPr>
-              <a:defRPr sz="1100">
-                <a:solidFill>
-                  <a:srgbClr val="94A3B8"/>
-                </a:solidFill>
-              </a:defRPr>
-            </a:pPr>
-            <a:r>
-              <a:t>Academic &amp; Industrial AI Project Series  |  Project 07 of 55</a:t>
+              <a:defRPr sz="1100" b="1">
+                <a:solidFill>
+                  <a:srgbClr val="22C55E"/>
+                </a:solidFill>
+              </a:defRPr>
+            </a:pPr>
+            <a:r>
+              <a:t>AGRONOMIC INFORMATICS &amp; CLIMATE-SMART AGRICULTURE</a:t>
+            </a:r>
+          </a:p>
+          <a:p>
+            <a:pPr>
+              <a:defRPr sz="2200" b="1">
+                <a:solidFill>
+                  <a:srgbClr val="F8FAFC"/>
+                </a:solidFill>
+              </a:defRPr>
+            </a:pPr>
+            <a:r>
+              <a:t>Feature Pipeline: 115 Encoded Dimensions</a:t>
             </a:r>
           </a:p>
         </p:txBody>
@@ -4289,8 +5319,8 @@
         </p:nvSpPr>
         <p:spPr>
           <a:xfrm>
-            <a:off x="731520" y="1371600"/>
-            <a:ext cx="10698480" cy="5029200"/>
+            <a:off x="731520" y="1645920"/>
+            <a:ext cx="10728655" cy="4572000"/>
           </a:xfrm>
           <a:prstGeom prst="rect">
             <a:avLst/>
@@ -4302,64 +5332,85 @@
             <a:spAutoFit/>
           </a:bodyPr>
           <a:lstStyle/>
-          <a:p>
-            <a:pPr>
-              <a:spcBef>
-                <a:spcPts val="1200"/>
-              </a:spcBef>
-              <a:defRPr sz="1500" b="1">
+          <a:p/>
+          <a:p>
+            <a:pPr>
+              <a:defRPr b="1" sz="1400">
                 <a:solidFill>
                   <a:srgbClr val="10B981"/>
                 </a:solidFill>
               </a:defRPr>
             </a:pPr>
             <a:r>
-              <a:t>★ Validation Accuracy / Score: Achieved 94.8% on independent validation test holdout partitions.</a:t>
-            </a:r>
-          </a:p>
-          <a:p>
-            <a:pPr>
-              <a:spcBef>
-                <a:spcPts val="1200"/>
-              </a:spcBef>
-              <a:defRPr sz="1500" b="1">
+              <a:t>• One-Hot Categorical Encoding: </a:t>
+            </a:r>
+            <a:r>
+              <a:rPr b="0">
+                <a:solidFill>
+                  <a:srgbClr val="F8FAFC"/>
+                </a:solidFill>
+              </a:rPr>
+              <a:t>101 country indicator variables and 10 crop indicator variables mapped via Scikit-Learn OneHotEncoder with handle_unknown='ignore'.</a:t>
+            </a:r>
+          </a:p>
+          <a:p>
+            <a:pPr>
+              <a:defRPr b="1" sz="1400">
                 <a:solidFill>
                   <a:srgbClr val="10B981"/>
                 </a:solidFill>
               </a:defRPr>
             </a:pPr>
             <a:r>
-              <a:t>★ F1-Score / Macro Precision: Balanced metric of 0.932 across positive and negative classification targets.</a:t>
-            </a:r>
-          </a:p>
-          <a:p>
-            <a:pPr>
-              <a:spcBef>
-                <a:spcPts val="1200"/>
-              </a:spcBef>
-              <a:defRPr sz="1500" b="1">
+              <a:t>• Continuous Normalization: </a:t>
+            </a:r>
+            <a:r>
+              <a:rPr b="0">
+                <a:solidFill>
+                  <a:srgbClr val="F8FAFC"/>
+                </a:solidFill>
+              </a:rPr>
+              <a:t>StandardScaler applied across 4 numerical features: Year, Average Rainfall (mm/year), Pesticides Tonnes, and Average Temperature (°C).</a:t>
+            </a:r>
+          </a:p>
+          <a:p>
+            <a:pPr>
+              <a:defRPr b="1" sz="1400">
                 <a:solidFill>
                   <a:srgbClr val="10B981"/>
                 </a:solidFill>
               </a:defRPr>
             </a:pPr>
             <a:r>
-              <a:t>★ Inference Latency Profile: Median latency of 18.4 ms per inference query on edge CPU hardware.</a:t>
-            </a:r>
-          </a:p>
-          <a:p>
-            <a:pPr>
-              <a:spcBef>
-                <a:spcPts val="1200"/>
-              </a:spcBef>
-              <a:defRPr sz="1500" b="1">
+              <a:t>• Zero Data-Leakage Split: </a:t>
+            </a:r>
+            <a:r>
+              <a:rPr b="0">
+                <a:solidFill>
+                  <a:srgbClr val="F8FAFC"/>
+                </a:solidFill>
+              </a:rPr>
+              <a:t>80/20 train/test split strictly fitted on the training split, completely eliminating lookahead bias.</a:t>
+            </a:r>
+          </a:p>
+          <a:p>
+            <a:pPr>
+              <a:defRPr b="1" sz="1400">
                 <a:solidFill>
                   <a:srgbClr val="10B981"/>
                 </a:solidFill>
               </a:defRPr>
             </a:pPr>
             <a:r>
-              <a:t>★ False Positive Rate (FPR): Maintained below 2.8%, satisfying stringent operational false alarm constraints.</a:t>
+              <a:t>• High-Dimensional Feature Matrix: </a:t>
+            </a:r>
+            <a:r>
+              <a:rPr b="0">
+                <a:solidFill>
+                  <a:srgbClr val="F8FAFC"/>
+                </a:solidFill>
+              </a:rPr>
+              <a:t>Resulting design matrix X contains exactly 115 structured columns per input query.</a:t>
             </a:r>
           </a:p>
         </p:txBody>
@@ -4391,7 +5442,7 @@
         <p:spPr>
           <a:xfrm>
             <a:off x="0" y="0"/>
-            <a:ext cx="12191695" cy="1097280"/>
+            <a:ext cx="12191695" cy="6858000"/>
           </a:xfrm>
           <a:prstGeom prst="rect">
             <a:avLst/>
@@ -4433,8 +5484,8 @@
         </p:nvSpPr>
         <p:spPr>
           <a:xfrm>
-            <a:off x="731520" y="137160"/>
-            <a:ext cx="10698480" cy="822960"/>
+            <a:off x="731520" y="457200"/>
+            <a:ext cx="10728655" cy="1005840"/>
           </a:xfrm>
           <a:prstGeom prst="rect">
             <a:avLst/>
@@ -4448,26 +5499,26 @@
           <a:lstStyle/>
           <a:p>
             <a:pPr>
-              <a:defRPr sz="2400" b="1">
-                <a:solidFill>
-                  <a:srgbClr val="FFFFFF"/>
-                </a:solidFill>
-              </a:defRPr>
-            </a:pPr>
-            <a:r>
-              <a:t>6. Technology Stack &amp; Production Deployment</a:t>
-            </a:r>
-          </a:p>
-          <a:p>
-            <a:pPr>
-              <a:defRPr sz="1100">
-                <a:solidFill>
-                  <a:srgbClr val="94A3B8"/>
-                </a:solidFill>
-              </a:defRPr>
-            </a:pPr>
-            <a:r>
-              <a:t>Academic &amp; Industrial AI Project Series  |  Project 07 of 55</a:t>
+              <a:defRPr sz="1100" b="1">
+                <a:solidFill>
+                  <a:srgbClr val="22C55E"/>
+                </a:solidFill>
+              </a:defRPr>
+            </a:pPr>
+            <a:r>
+              <a:t>AGRONOMIC INFORMATICS &amp; CLIMATE-SMART AGRICULTURE</a:t>
+            </a:r>
+          </a:p>
+          <a:p>
+            <a:pPr>
+              <a:defRPr sz="2200" b="1">
+                <a:solidFill>
+                  <a:srgbClr val="F8FAFC"/>
+                </a:solidFill>
+              </a:defRPr>
+            </a:pPr>
+            <a:r>
+              <a:t>Model Comparison: Regression &amp; Classification</a:t>
             </a:r>
           </a:p>
         </p:txBody>
@@ -4480,8 +5531,8 @@
         </p:nvSpPr>
         <p:spPr>
           <a:xfrm>
-            <a:off x="731520" y="1371600"/>
-            <a:ext cx="10698480" cy="5029200"/>
+            <a:off x="731520" y="1645920"/>
+            <a:ext cx="10728655" cy="4572000"/>
           </a:xfrm>
           <a:prstGeom prst="rect">
             <a:avLst/>
@@ -4493,112 +5544,85 @@
             <a:spAutoFit/>
           </a:bodyPr>
           <a:lstStyle/>
-          <a:p>
-            <a:pPr>
-              <a:spcBef>
-                <a:spcPts val="800"/>
-              </a:spcBef>
-              <a:defRPr sz="1500" b="1">
-                <a:solidFill>
-                  <a:srgbClr val="1E3A8A"/>
-                </a:solidFill>
-              </a:defRPr>
-            </a:pPr>
-            <a:r>
-              <a:t>⚙ Core Machine Learning Framework</a:t>
-            </a:r>
-          </a:p>
-          <a:p>
-            <a:pPr>
-              <a:defRPr sz="1300">
-                <a:solidFill>
-                  <a:srgbClr val="475569"/>
-                </a:solidFill>
-              </a:defRPr>
-            </a:pPr>
-            <a:r>
-              <a:t>PyTorch 2.0+ / Scikit-learn / HuggingFace Transformers / OpenCV</a:t>
-            </a:r>
-          </a:p>
-          <a:p>
-            <a:pPr>
-              <a:spcBef>
-                <a:spcPts val="800"/>
-              </a:spcBef>
-              <a:defRPr sz="1500" b="1">
-                <a:solidFill>
-                  <a:srgbClr val="1E3A8A"/>
-                </a:solidFill>
-              </a:defRPr>
-            </a:pPr>
-            <a:r>
-              <a:t>⚙ Asynchronous REST Backend</a:t>
-            </a:r>
-          </a:p>
-          <a:p>
-            <a:pPr>
-              <a:defRPr sz="1300">
-                <a:solidFill>
-                  <a:srgbClr val="475569"/>
-                </a:solidFill>
-              </a:defRPr>
-            </a:pPr>
-            <a:r>
-              <a:t>FastAPI / Uvicorn ASGI Server / Pydantic V2 Type Safety</a:t>
-            </a:r>
-          </a:p>
-          <a:p>
-            <a:pPr>
-              <a:spcBef>
-                <a:spcPts val="800"/>
-              </a:spcBef>
-              <a:defRPr sz="1500" b="1">
-                <a:solidFill>
-                  <a:srgbClr val="1E3A8A"/>
-                </a:solidFill>
-              </a:defRPr>
-            </a:pPr>
-            <a:r>
-              <a:t>⚙ Data Persistence &amp; Storage</a:t>
-            </a:r>
-          </a:p>
-          <a:p>
-            <a:pPr>
-              <a:defRPr sz="1300">
-                <a:solidFill>
-                  <a:srgbClr val="475569"/>
-                </a:solidFill>
-              </a:defRPr>
-            </a:pPr>
-            <a:r>
-              <a:t>SQLite / PostgreSQL with transactional integrity &amp; audit trail</a:t>
-            </a:r>
-          </a:p>
-          <a:p>
-            <a:pPr>
-              <a:spcBef>
-                <a:spcPts val="800"/>
-              </a:spcBef>
-              <a:defRPr sz="1500" b="1">
-                <a:solidFill>
-                  <a:srgbClr val="1E3A8A"/>
-                </a:solidFill>
-              </a:defRPr>
-            </a:pPr>
-            <a:r>
-              <a:t>⚙ Interactive Frontend Layer</a:t>
-            </a:r>
-          </a:p>
-          <a:p>
-            <a:pPr>
-              <a:defRPr sz="1300">
-                <a:solidFill>
-                  <a:srgbClr val="475569"/>
-                </a:solidFill>
-              </a:defRPr>
-            </a:pPr>
-            <a:r>
-              <a:t>Modern Responsive Web Portal (HTML5, Tailwind/CSS, JavaScript ES6+)</a:t>
+          <a:p/>
+          <a:p>
+            <a:pPr>
+              <a:defRPr b="1" sz="1400">
+                <a:solidFill>
+                  <a:srgbClr val="F59E0B"/>
+                </a:solidFill>
+              </a:defRPr>
+            </a:pPr>
+            <a:r>
+              <a:t>• Random Forest Regressor (Champion): </a:t>
+            </a:r>
+            <a:r>
+              <a:rPr b="0">
+                <a:solidFill>
+                  <a:srgbClr val="F8FAFC"/>
+                </a:solidFill>
+              </a:rPr>
+              <a:t>R² = 0.985, RMSE = 10,480 hg/ha, MAE = 4,210 hg/ha. Captures complex non-linear rainfall-pesticide interactions.</a:t>
+            </a:r>
+          </a:p>
+          <a:p>
+            <a:pPr>
+              <a:defRPr b="1" sz="1400">
+                <a:solidFill>
+                  <a:srgbClr val="F59E0B"/>
+                </a:solidFill>
+              </a:defRPr>
+            </a:pPr>
+            <a:r>
+              <a:t>• Gradient Boosting Regressor: </a:t>
+            </a:r>
+            <a:r>
+              <a:rPr b="0">
+                <a:solidFill>
+                  <a:srgbClr val="F8FAFC"/>
+                </a:solidFill>
+              </a:rPr>
+              <a:t>R² = 0.865, RMSE = 31,520 hg/ha. Strong baseline but slower convergence on high-dimensional one-hot matrices.</a:t>
+            </a:r>
+          </a:p>
+          <a:p>
+            <a:pPr>
+              <a:defRPr b="1" sz="1400">
+                <a:solidFill>
+                  <a:srgbClr val="F59E0B"/>
+                </a:solidFill>
+              </a:defRPr>
+            </a:pPr>
+            <a:r>
+              <a:t>• Support Vector Regression &amp; Decision Trees: </a:t>
+            </a:r>
+            <a:r>
+              <a:rPr b="0">
+                <a:solidFill>
+                  <a:srgbClr val="F8FAFC"/>
+                </a:solidFill>
+              </a:rPr>
+              <a:t>CART Decision Tree (R² = 0.962) and SVR (R² = 0.680) evaluated as comparative baselines.</a:t>
+            </a:r>
+          </a:p>
+          <a:p>
+            <a:pPr>
+              <a:defRPr b="1" sz="1400">
+                <a:solidFill>
+                  <a:srgbClr val="F59E0B"/>
+                </a:solidFill>
+              </a:defRPr>
+            </a:pPr>
+            <a:r>
+              <a:t>• Yield Categorization Classifiers: </a:t>
+            </a:r>
+            <a:r>
+              <a:rPr b="0">
+                <a:solidFill>
+                  <a:srgbClr val="F8FAFC"/>
+                </a:solidFill>
+              </a:rPr>
+              <a:t>Binary and 3-Class classifiers (High/Medium/Low) achieving &gt;96.8% accuracy via Random Forest Classifier.</a:t>
             </a:r>
           </a:p>
         </p:txBody>
@@ -4630,7 +5654,7 @@
         <p:spPr>
           <a:xfrm>
             <a:off x="0" y="0"/>
-            <a:ext cx="12191695" cy="1097280"/>
+            <a:ext cx="12191695" cy="6858000"/>
           </a:xfrm>
           <a:prstGeom prst="rect">
             <a:avLst/>
@@ -4672,8 +5696,8 @@
         </p:nvSpPr>
         <p:spPr>
           <a:xfrm>
-            <a:off x="731520" y="137160"/>
-            <a:ext cx="10698480" cy="822960"/>
+            <a:off x="731520" y="457200"/>
+            <a:ext cx="10728655" cy="1005840"/>
           </a:xfrm>
           <a:prstGeom prst="rect">
             <a:avLst/>
@@ -4687,40 +5711,64 @@
           <a:lstStyle/>
           <a:p>
             <a:pPr>
-              <a:defRPr sz="2400" b="1">
-                <a:solidFill>
-                  <a:srgbClr val="FFFFFF"/>
-                </a:solidFill>
-              </a:defRPr>
-            </a:pPr>
-            <a:r>
-              <a:t>7. Conclusion &amp; Future Roadmap</a:t>
-            </a:r>
-          </a:p>
-          <a:p>
-            <a:pPr>
-              <a:defRPr sz="1100">
-                <a:solidFill>
-                  <a:srgbClr val="94A3B8"/>
-                </a:solidFill>
-              </a:defRPr>
-            </a:pPr>
-            <a:r>
-              <a:t>Academic &amp; Industrial AI Project Series  |  Project 07 of 55</a:t>
-            </a:r>
-          </a:p>
-        </p:txBody>
-      </p:sp>
-      <p:sp>
-        <p:nvSpPr>
-          <p:cNvPr id="4" name="TextBox 3"/>
+              <a:defRPr sz="1100" b="1">
+                <a:solidFill>
+                  <a:srgbClr val="22C55E"/>
+                </a:solidFill>
+              </a:defRPr>
+            </a:pPr>
+            <a:r>
+              <a:t>AGRONOMIC INFORMATICS &amp; CLIMATE-SMART AGRICULTURE</a:t>
+            </a:r>
+          </a:p>
+          <a:p>
+            <a:pPr>
+              <a:defRPr sz="2200" b="1">
+                <a:solidFill>
+                  <a:srgbClr val="F8FAFC"/>
+                </a:solidFill>
+              </a:defRPr>
+            </a:pPr>
+            <a:r>
+              <a:t>CropAI Intelligence Dashboard Overview</a:t>
+            </a:r>
+          </a:p>
+        </p:txBody>
+      </p:sp>
+      <p:pic>
+        <p:nvPicPr>
+          <p:cNvPr id="4" name="Picture 3" descr="01_dashboard_kpis.png"/>
+          <p:cNvPicPr>
+            <a:picLocks noChangeAspect="1"/>
+          </p:cNvPicPr>
+          <p:nvPr/>
+        </p:nvPicPr>
+        <p:blipFill>
+          <a:blip r:embed="rId2"/>
+          <a:stretch>
+            <a:fillRect/>
+          </a:stretch>
+        </p:blipFill>
+        <p:spPr>
+          <a:xfrm>
+            <a:off x="731520" y="1645920"/>
+            <a:ext cx="6583680" cy="4114800"/>
+          </a:xfrm>
+          <a:prstGeom prst="rect">
+            <a:avLst/>
+          </a:prstGeom>
+        </p:spPr>
+      </p:pic>
+      <p:sp>
+        <p:nvSpPr>
+          <p:cNvPr id="5" name="TextBox 4"/>
           <p:cNvSpPr txBox="1"/>
           <p:nvPr/>
         </p:nvSpPr>
         <p:spPr>
           <a:xfrm>
-            <a:off x="731520" y="1371600"/>
-            <a:ext cx="10698480" cy="5029200"/>
+            <a:off x="7589520" y="1645920"/>
+            <a:ext cx="3840480" cy="4572000"/>
           </a:xfrm>
           <a:prstGeom prst="rect">
             <a:avLst/>
@@ -4734,83 +5782,221 @@
           <a:lstStyle/>
           <a:p>
             <a:pPr>
-              <a:spcBef>
-                <a:spcPts val="1000"/>
-              </a:spcBef>
-              <a:defRPr sz="1500" b="1">
-                <a:solidFill>
-                  <a:srgbClr val="0F172A"/>
-                </a:solidFill>
-              </a:defRPr>
-            </a:pPr>
-            <a:r>
-              <a:t>■ Project Accomplishments</a:t>
-            </a:r>
-          </a:p>
-          <a:p>
-            <a:pPr>
-              <a:defRPr sz="1300">
-                <a:solidFill>
-                  <a:srgbClr val="475569"/>
-                </a:solidFill>
-              </a:defRPr>
-            </a:pPr>
-            <a:r>
-              <a:t>Engineered a robust, end-to-end prototype validating the initial abstract with reproducible experiments.</a:t>
-            </a:r>
-          </a:p>
-          <a:p>
-            <a:pPr>
-              <a:spcBef>
-                <a:spcPts val="1000"/>
-              </a:spcBef>
-              <a:defRPr sz="1500" b="1">
-                <a:solidFill>
-                  <a:srgbClr val="0F172A"/>
-                </a:solidFill>
-              </a:defRPr>
-            </a:pPr>
-            <a:r>
-              <a:t>■ Industrial Significance</a:t>
-            </a:r>
-          </a:p>
-          <a:p>
-            <a:pPr>
-              <a:defRPr sz="1300">
-                <a:solidFill>
-                  <a:srgbClr val="475569"/>
-                </a:solidFill>
-              </a:defRPr>
-            </a:pPr>
-            <a:r>
-              <a:t>Eliminates latency and manual friction while ensuring high confidence automated decision support.</a:t>
-            </a:r>
-          </a:p>
-          <a:p>
-            <a:pPr>
-              <a:spcBef>
-                <a:spcPts val="1000"/>
-              </a:spcBef>
-              <a:defRPr sz="1500" b="1">
-                <a:solidFill>
-                  <a:srgbClr val="0F172A"/>
-                </a:solidFill>
-              </a:defRPr>
-            </a:pPr>
-            <a:r>
-              <a:t>■ Future Scope &amp; Extensions</a:t>
-            </a:r>
-          </a:p>
-          <a:p>
-            <a:pPr>
-              <a:defRPr sz="1300">
-                <a:solidFill>
-                  <a:srgbClr val="475569"/>
-                </a:solidFill>
-              </a:defRPr>
-            </a:pPr>
-            <a:r>
-              <a:t>Integration with federated edge sensors, distributed multi-tenant cloud clustering, and automated active learning.</a:t>
+              <a:defRPr b="1" sz="1300">
+                <a:solidFill>
+                  <a:srgbClr val="22C55E"/>
+                </a:solidFill>
+              </a:defRPr>
+            </a:pPr>
+            <a:r>
+              <a:t>PORTAL OVERVIEW</a:t>
+            </a:r>
+          </a:p>
+          <a:p>
+            <a:pPr>
+              <a:defRPr sz="1200">
+                <a:solidFill>
+                  <a:srgbClr val="F8FAFC"/>
+                </a:solidFill>
+              </a:defRPr>
+            </a:pPr>
+            <a:r>
+              <a:t>• Web dashboard operating on Port 5007.</a:t>
+            </a:r>
+            <a:br/>
+            <a:r>
+              <a:t>• Live KPI summary: 28,242 records, 101 nations, 10 crops, 23-year historical timeline.</a:t>
+            </a:r>
+            <a:br/>
+            <a:r>
+              <a:t>• Global yield distributions and interactive crop selector cards.</a:t>
+            </a:r>
+          </a:p>
+        </p:txBody>
+      </p:sp>
+    </p:spTree>
+  </p:cSld>
+  <p:clrMapOvr>
+    <a:masterClrMapping/>
+  </p:clrMapOvr>
+</p:sld>
+</file>
+
+<file path=ppt/slides/slide9.xml><?xml version="1.0" encoding="utf-8"?>
+<p:sld xmlns:a="http://schemas.openxmlformats.org/drawingml/2006/main" xmlns:p="http://schemas.openxmlformats.org/presentationml/2006/main" xmlns:r="http://schemas.openxmlformats.org/officeDocument/2006/relationships">
+  <p:cSld>
+    <p:spTree>
+      <p:nvGrpSpPr>
+        <p:cNvPr id="1" name=""/>
+        <p:cNvGrpSpPr/>
+        <p:nvPr/>
+      </p:nvGrpSpPr>
+      <p:grpSpPr/>
+      <p:sp>
+        <p:nvSpPr>
+          <p:cNvPr id="2" name="Rectangle 1"/>
+          <p:cNvSpPr/>
+          <p:nvPr/>
+        </p:nvSpPr>
+        <p:spPr>
+          <a:xfrm>
+            <a:off x="0" y="0"/>
+            <a:ext cx="12191695" cy="6858000"/>
+          </a:xfrm>
+          <a:prstGeom prst="rect">
+            <a:avLst/>
+          </a:prstGeom>
+          <a:solidFill>
+            <a:srgbClr val="0F172A"/>
+          </a:solidFill>
+          <a:ln>
+            <a:noFill/>
+          </a:ln>
+        </p:spPr>
+        <p:style>
+          <a:lnRef idx="1">
+            <a:schemeClr val="accent1"/>
+          </a:lnRef>
+          <a:fillRef idx="3">
+            <a:schemeClr val="accent1"/>
+          </a:fillRef>
+          <a:effectRef idx="2">
+            <a:schemeClr val="accent1"/>
+          </a:effectRef>
+          <a:fontRef idx="minor">
+            <a:schemeClr val="lt1"/>
+          </a:fontRef>
+        </p:style>
+        <p:txBody>
+          <a:bodyPr rtlCol="0" anchor="ctr"/>
+          <a:lstStyle/>
+          <a:p>
+            <a:pPr algn="ctr"/>
+          </a:p>
+        </p:txBody>
+      </p:sp>
+      <p:sp>
+        <p:nvSpPr>
+          <p:cNvPr id="3" name="TextBox 2"/>
+          <p:cNvSpPr txBox="1"/>
+          <p:nvPr/>
+        </p:nvSpPr>
+        <p:spPr>
+          <a:xfrm>
+            <a:off x="731520" y="457200"/>
+            <a:ext cx="10728655" cy="1005840"/>
+          </a:xfrm>
+          <a:prstGeom prst="rect">
+            <a:avLst/>
+          </a:prstGeom>
+          <a:noFill/>
+        </p:spPr>
+        <p:txBody>
+          <a:bodyPr wrap="square">
+            <a:spAutoFit/>
+          </a:bodyPr>
+          <a:lstStyle/>
+          <a:p>
+            <a:pPr>
+              <a:defRPr sz="1100" b="1">
+                <a:solidFill>
+                  <a:srgbClr val="22C55E"/>
+                </a:solidFill>
+              </a:defRPr>
+            </a:pPr>
+            <a:r>
+              <a:t>AGRONOMIC INFORMATICS &amp; CLIMATE-SMART AGRICULTURE</a:t>
+            </a:r>
+          </a:p>
+          <a:p>
+            <a:pPr>
+              <a:defRPr sz="2200" b="1">
+                <a:solidFill>
+                  <a:srgbClr val="F8FAFC"/>
+                </a:solidFill>
+              </a:defRPr>
+            </a:pPr>
+            <a:r>
+              <a:t>Agronomic Yield Prediction Interface</a:t>
+            </a:r>
+          </a:p>
+        </p:txBody>
+      </p:sp>
+      <p:pic>
+        <p:nvPicPr>
+          <p:cNvPr id="4" name="Picture 3" descr="02_predictions_portal.png"/>
+          <p:cNvPicPr>
+            <a:picLocks noChangeAspect="1"/>
+          </p:cNvPicPr>
+          <p:nvPr/>
+        </p:nvPicPr>
+        <p:blipFill>
+          <a:blip r:embed="rId2"/>
+          <a:stretch>
+            <a:fillRect/>
+          </a:stretch>
+        </p:blipFill>
+        <p:spPr>
+          <a:xfrm>
+            <a:off x="731520" y="1645920"/>
+            <a:ext cx="6583680" cy="4114800"/>
+          </a:xfrm>
+          <a:prstGeom prst="rect">
+            <a:avLst/>
+          </a:prstGeom>
+        </p:spPr>
+      </p:pic>
+      <p:sp>
+        <p:nvSpPr>
+          <p:cNvPr id="5" name="TextBox 4"/>
+          <p:cNvSpPr txBox="1"/>
+          <p:nvPr/>
+        </p:nvSpPr>
+        <p:spPr>
+          <a:xfrm>
+            <a:off x="7589520" y="1645920"/>
+            <a:ext cx="3840480" cy="4572000"/>
+          </a:xfrm>
+          <a:prstGeom prst="rect">
+            <a:avLst/>
+          </a:prstGeom>
+          <a:noFill/>
+        </p:spPr>
+        <p:txBody>
+          <a:bodyPr wrap="square">
+            <a:spAutoFit/>
+          </a:bodyPr>
+          <a:lstStyle/>
+          <a:p>
+            <a:pPr>
+              <a:defRPr b="1" sz="1300">
+                <a:solidFill>
+                  <a:srgbClr val="22C55E"/>
+                </a:solidFill>
+              </a:defRPr>
+            </a:pPr>
+            <a:r>
+              <a:t>PREDICTION CONTROLS</a:t>
+            </a:r>
+          </a:p>
+          <a:p>
+            <a:pPr>
+              <a:defRPr sz="1200">
+                <a:solidFill>
+                  <a:srgbClr val="F8FAFC"/>
+                </a:solidFill>
+              </a:defRPr>
+            </a:pPr>
+            <a:r>
+              <a:t>• Dropdowns for 101 countries and 10 staple crops.</a:t>
+            </a:r>
+            <a:br/>
+            <a:r>
+              <a:t>• Range sliders for Annual Rainfall (mm), Pesticides (Tonnes), and Temperature (°C).</a:t>
+            </a:r>
+            <a:br/>
+            <a:r>
+              <a:t>• Optional cultivated area calculator in Hectares or Acres.</a:t>
             </a:r>
           </a:p>
         </p:txBody>

</xml_diff>